<commit_message>
Fix: Agenda slide update (Telegram+Wokwi), gitignore lengkap, link panduan jadi raw URL
</commit_message>
<xml_diff>
--- a/IoT_untuk_Peternakan_UNMUL.pptx
+++ b/IoT_untuk_Peternakan_UNMUL.pptx
@@ -11744,7 +11744,7 @@
           <a:lstStyle/>
           <a:p>
             <a:pPr algn="ctr"/>
-            <a:endParaRPr/>
+            <a:endParaRPr sz="2400"/>
           </a:p>
         </p:txBody>
       </p:sp>
@@ -11788,7 +11788,7 @@
           <a:lstStyle/>
           <a:p>
             <a:pPr algn="ctr"/>
-            <a:endParaRPr/>
+            <a:endParaRPr sz="2400"/>
           </a:p>
         </p:txBody>
       </p:sp>
@@ -11832,7 +11832,7 @@
           <a:lstStyle/>
           <a:p>
             <a:pPr algn="ctr"/>
-            <a:endParaRPr/>
+            <a:endParaRPr sz="2400"/>
           </a:p>
         </p:txBody>
       </p:sp>
@@ -11845,7 +11845,7 @@
         <p:spPr>
           <a:xfrm>
             <a:off x="365760" y="274320"/>
-            <a:ext cx="11430000" cy="731520"/>
+            <a:ext cx="11430000" cy="646331"/>
           </a:xfrm>
           <a:prstGeom prst="rect">
             <a:avLst/>
@@ -11860,7 +11860,7 @@
           <a:p>
             <a:pPr algn="l"/>
             <a:r>
-              <a:rPr sz="3000" b="1" i="0">
+              <a:rPr sz="3600" b="1" i="0">
                 <a:solidFill>
                   <a:srgbClr val="FFFFFF"/>
                 </a:solidFill>
@@ -11880,7 +11880,7 @@
         <p:spPr>
           <a:xfrm>
             <a:off x="365760" y="1325880"/>
-            <a:ext cx="11430000" cy="411480"/>
+            <a:ext cx="11430000" cy="369332"/>
           </a:xfrm>
           <a:prstGeom prst="rect">
             <a:avLst/>
@@ -11895,7 +11895,7 @@
           <a:p>
             <a:pPr algn="l"/>
             <a:r>
-              <a:rPr sz="1400" b="0" i="1">
+              <a:rPr b="0" i="1">
                 <a:solidFill>
                   <a:srgbClr val="6FBF73"/>
                 </a:solidFill>
@@ -11948,7 +11948,7 @@
           <a:lstStyle/>
           <a:p>
             <a:pPr algn="ctr"/>
-            <a:endParaRPr/>
+            <a:endParaRPr sz="2400"/>
           </a:p>
         </p:txBody>
       </p:sp>
@@ -11961,22 +11961,22 @@
         <p:spPr>
           <a:xfrm>
             <a:off x="274320" y="1938528"/>
-            <a:ext cx="2788920" cy="713232"/>
-          </a:xfrm>
-          <a:prstGeom prst="rect">
-            <a:avLst/>
-          </a:prstGeom>
-          <a:noFill/>
-        </p:spPr>
-        <p:txBody>
-          <a:bodyPr wrap="square">
-            <a:spAutoFit/>
-          </a:bodyPr>
-          <a:lstStyle/>
-          <a:p>
-            <a:pPr algn="ctr"/>
-            <a:r>
-              <a:rPr sz="3200" b="0" i="0">
+            <a:ext cx="2788920" cy="707886"/>
+          </a:xfrm>
+          <a:prstGeom prst="rect">
+            <a:avLst/>
+          </a:prstGeom>
+          <a:noFill/>
+        </p:spPr>
+        <p:txBody>
+          <a:bodyPr wrap="square">
+            <a:spAutoFit/>
+          </a:bodyPr>
+          <a:lstStyle/>
+          <a:p>
+            <a:pPr algn="ctr"/>
+            <a:r>
+              <a:rPr sz="4000" b="0" i="0">
                 <a:solidFill>
                   <a:srgbClr val="FFFFFF"/>
                 </a:solidFill>
@@ -11996,22 +11996,22 @@
         <p:spPr>
           <a:xfrm>
             <a:off x="365760" y="2651760"/>
-            <a:ext cx="2606040" cy="457200"/>
-          </a:xfrm>
-          <a:prstGeom prst="rect">
-            <a:avLst/>
-          </a:prstGeom>
-          <a:noFill/>
-        </p:spPr>
-        <p:txBody>
-          <a:bodyPr wrap="square">
-            <a:spAutoFit/>
-          </a:bodyPr>
-          <a:lstStyle/>
-          <a:p>
-            <a:pPr algn="ctr"/>
-            <a:r>
-              <a:rPr sz="1600" b="1" i="0">
+            <a:ext cx="2606040" cy="400110"/>
+          </a:xfrm>
+          <a:prstGeom prst="rect">
+            <a:avLst/>
+          </a:prstGeom>
+          <a:noFill/>
+        </p:spPr>
+        <p:txBody>
+          <a:bodyPr wrap="square">
+            <a:spAutoFit/>
+          </a:bodyPr>
+          <a:lstStyle/>
+          <a:p>
+            <a:pPr algn="ctr"/>
+            <a:r>
+              <a:rPr sz="2000" b="1" i="0">
                 <a:solidFill>
                   <a:srgbClr val="F5A623"/>
                 </a:solidFill>
@@ -12062,7 +12062,7 @@
           <a:lstStyle/>
           <a:p>
             <a:pPr algn="ctr"/>
-            <a:endParaRPr/>
+            <a:endParaRPr sz="2400"/>
           </a:p>
         </p:txBody>
       </p:sp>
@@ -12075,22 +12075,22 @@
         <p:spPr>
           <a:xfrm>
             <a:off x="384048" y="3182112"/>
-            <a:ext cx="2569464" cy="1188720"/>
-          </a:xfrm>
-          <a:prstGeom prst="rect">
-            <a:avLst/>
-          </a:prstGeom>
-          <a:noFill/>
-        </p:spPr>
-        <p:txBody>
-          <a:bodyPr wrap="square">
-            <a:spAutoFit/>
-          </a:bodyPr>
-          <a:lstStyle/>
-          <a:p>
-            <a:pPr algn="ctr"/>
-            <a:r>
-              <a:rPr sz="1250" b="0" i="0">
+            <a:ext cx="2569464" cy="1077218"/>
+          </a:xfrm>
+          <a:prstGeom prst="rect">
+            <a:avLst/>
+          </a:prstGeom>
+          <a:noFill/>
+        </p:spPr>
+        <p:txBody>
+          <a:bodyPr wrap="square">
+            <a:spAutoFit/>
+          </a:bodyPr>
+          <a:lstStyle/>
+          <a:p>
+            <a:pPr algn="ctr"/>
+            <a:r>
+              <a:rPr sz="1600" b="0" i="0">
                 <a:solidFill>
                   <a:srgbClr val="F5F5F0"/>
                 </a:solidFill>
@@ -12145,7 +12145,7 @@
           <a:lstStyle/>
           <a:p>
             <a:pPr algn="ctr"/>
-            <a:endParaRPr/>
+            <a:endParaRPr sz="2400"/>
           </a:p>
         </p:txBody>
       </p:sp>
@@ -12158,7 +12158,7 @@
         <p:spPr>
           <a:xfrm>
             <a:off x="457200" y="4480560"/>
-            <a:ext cx="2423160" cy="1737360"/>
+            <a:ext cx="2423160" cy="1323439"/>
           </a:xfrm>
           <a:prstGeom prst="rect">
             <a:avLst/>
@@ -12173,14 +12173,86 @@
           <a:p>
             <a:pPr algn="l"/>
             <a:r>
-              <a:rPr sz="1150" b="0" i="0">
+              <a:rPr sz="1600" b="0" i="0" dirty="0">
                 <a:solidFill>
                   <a:srgbClr val="6FBF73"/>
                 </a:solidFill>
                 <a:latin typeface="Calibri"/>
               </a:rPr>
-              <a:t>🔍 Kata kunci pencarian:
-• 'Smart Farming Sawit Kaltim'
+              <a:t>🔍 Kata </a:t>
+            </a:r>
+            <a:r>
+              <a:rPr sz="1600" b="0" i="0" dirty="0" err="1">
+                <a:solidFill>
+                  <a:srgbClr val="6FBF73"/>
+                </a:solidFill>
+                <a:latin typeface="Calibri"/>
+              </a:rPr>
+              <a:t>kunci</a:t>
+            </a:r>
+            <a:r>
+              <a:rPr sz="1600" b="0" i="0" dirty="0">
+                <a:solidFill>
+                  <a:srgbClr val="6FBF73"/>
+                </a:solidFill>
+                <a:latin typeface="Calibri"/>
+              </a:rPr>
+              <a:t> </a:t>
+            </a:r>
+            <a:r>
+              <a:rPr sz="1600" b="0" i="0" dirty="0" err="1">
+                <a:solidFill>
+                  <a:srgbClr val="6FBF73"/>
+                </a:solidFill>
+                <a:latin typeface="Calibri"/>
+              </a:rPr>
+              <a:t>pencarian</a:t>
+            </a:r>
+            <a:r>
+              <a:rPr sz="1600" b="0" i="0" dirty="0">
+                <a:solidFill>
+                  <a:srgbClr val="6FBF73"/>
+                </a:solidFill>
+                <a:latin typeface="Calibri"/>
+              </a:rPr>
+              <a:t>:
+• 'Smart Farming </a:t>
+            </a:r>
+            <a:r>
+              <a:rPr sz="1600" b="0" i="0" dirty="0" err="1">
+                <a:solidFill>
+                  <a:srgbClr val="6FBF73"/>
+                </a:solidFill>
+                <a:latin typeface="Calibri"/>
+              </a:rPr>
+              <a:t>Sawit</a:t>
+            </a:r>
+            <a:r>
+              <a:rPr sz="1600" b="0" i="0" dirty="0">
+                <a:solidFill>
+                  <a:srgbClr val="6FBF73"/>
+                </a:solidFill>
+                <a:latin typeface="Calibri"/>
+              </a:rPr>
+              <a:t> </a:t>
+            </a:r>
+            <a:r>
+              <a:rPr sz="1600" b="0" i="0" dirty="0" err="1">
+                <a:solidFill>
+                  <a:srgbClr val="6FBF73"/>
+                </a:solidFill>
+                <a:latin typeface="Calibri"/>
+              </a:rPr>
+              <a:t>Kaltim</a:t>
+            </a:r>
+            <a:r>
+              <a:rPr sz="1600" b="0" i="0" dirty="0">
+                <a:solidFill>
+                  <a:srgbClr val="6FBF73"/>
+                </a:solidFill>
+                <a:latin typeface="Calibri"/>
+              </a:rPr>
+              <a:t>'
 • 'Internet of Things Livestock'</a:t>
             </a:r>
           </a:p>
@@ -12228,7 +12300,7 @@
           <a:lstStyle/>
           <a:p>
             <a:pPr algn="ctr"/>
-            <a:endParaRPr/>
+            <a:endParaRPr sz="2400"/>
           </a:p>
         </p:txBody>
       </p:sp>
@@ -12241,22 +12313,22 @@
         <p:spPr>
           <a:xfrm>
             <a:off x="3154680" y="1938528"/>
-            <a:ext cx="2788920" cy="713232"/>
-          </a:xfrm>
-          <a:prstGeom prst="rect">
-            <a:avLst/>
-          </a:prstGeom>
-          <a:noFill/>
-        </p:spPr>
-        <p:txBody>
-          <a:bodyPr wrap="square">
-            <a:spAutoFit/>
-          </a:bodyPr>
-          <a:lstStyle/>
-          <a:p>
-            <a:pPr algn="ctr"/>
-            <a:r>
-              <a:rPr sz="3200" b="0" i="0">
+            <a:ext cx="2788920" cy="707886"/>
+          </a:xfrm>
+          <a:prstGeom prst="rect">
+            <a:avLst/>
+          </a:prstGeom>
+          <a:noFill/>
+        </p:spPr>
+        <p:txBody>
+          <a:bodyPr wrap="square">
+            <a:spAutoFit/>
+          </a:bodyPr>
+          <a:lstStyle/>
+          <a:p>
+            <a:pPr algn="ctr"/>
+            <a:r>
+              <a:rPr sz="4000" b="0" i="0">
                 <a:solidFill>
                   <a:srgbClr val="FFFFFF"/>
                 </a:solidFill>
@@ -12276,22 +12348,22 @@
         <p:spPr>
           <a:xfrm>
             <a:off x="3246120" y="2651760"/>
-            <a:ext cx="2606040" cy="457200"/>
-          </a:xfrm>
-          <a:prstGeom prst="rect">
-            <a:avLst/>
-          </a:prstGeom>
-          <a:noFill/>
-        </p:spPr>
-        <p:txBody>
-          <a:bodyPr wrap="square">
-            <a:spAutoFit/>
-          </a:bodyPr>
-          <a:lstStyle/>
-          <a:p>
-            <a:pPr algn="ctr"/>
-            <a:r>
-              <a:rPr sz="1600" b="1" i="0">
+            <a:ext cx="2606040" cy="400110"/>
+          </a:xfrm>
+          <a:prstGeom prst="rect">
+            <a:avLst/>
+          </a:prstGeom>
+          <a:noFill/>
+        </p:spPr>
+        <p:txBody>
+          <a:bodyPr wrap="square">
+            <a:spAutoFit/>
+          </a:bodyPr>
+          <a:lstStyle/>
+          <a:p>
+            <a:pPr algn="ctr"/>
+            <a:r>
+              <a:rPr sz="2000" b="1" i="0">
                 <a:solidFill>
                   <a:srgbClr val="F5A623"/>
                 </a:solidFill>
@@ -12342,7 +12414,7 @@
           <a:lstStyle/>
           <a:p>
             <a:pPr algn="ctr"/>
-            <a:endParaRPr/>
+            <a:endParaRPr sz="2400"/>
           </a:p>
         </p:txBody>
       </p:sp>
@@ -12355,22 +12427,22 @@
         <p:spPr>
           <a:xfrm>
             <a:off x="3264408" y="3182112"/>
-            <a:ext cx="2569464" cy="1188720"/>
-          </a:xfrm>
-          <a:prstGeom prst="rect">
-            <a:avLst/>
-          </a:prstGeom>
-          <a:noFill/>
-        </p:spPr>
-        <p:txBody>
-          <a:bodyPr wrap="square">
-            <a:spAutoFit/>
-          </a:bodyPr>
-          <a:lstStyle/>
-          <a:p>
-            <a:pPr algn="ctr"/>
-            <a:r>
-              <a:rPr sz="1250" b="0" i="0">
+            <a:ext cx="2569464" cy="830997"/>
+          </a:xfrm>
+          <a:prstGeom prst="rect">
+            <a:avLst/>
+          </a:prstGeom>
+          <a:noFill/>
+        </p:spPr>
+        <p:txBody>
+          <a:bodyPr wrap="square">
+            <a:spAutoFit/>
+          </a:bodyPr>
+          <a:lstStyle/>
+          <a:p>
+            <a:pPr algn="ctr"/>
+            <a:r>
+              <a:rPr sz="1600" b="0" i="0">
                 <a:solidFill>
                   <a:srgbClr val="F5F5F0"/>
                 </a:solidFill>
@@ -12425,7 +12497,7 @@
           <a:lstStyle/>
           <a:p>
             <a:pPr algn="ctr"/>
-            <a:endParaRPr/>
+            <a:endParaRPr sz="2400"/>
           </a:p>
         </p:txBody>
       </p:sp>
@@ -12438,7 +12510,7 @@
         <p:spPr>
           <a:xfrm>
             <a:off x="3337560" y="4480560"/>
-            <a:ext cx="2423160" cy="1737360"/>
+            <a:ext cx="2423160" cy="1077218"/>
           </a:xfrm>
           <a:prstGeom prst="rect">
             <a:avLst/>
@@ -12453,7 +12525,7 @@
           <a:p>
             <a:pPr algn="l"/>
             <a:r>
-              <a:rPr sz="1150" b="0" i="0">
+              <a:rPr sz="1600" b="0" i="0">
                 <a:solidFill>
                   <a:srgbClr val="6FBF73"/>
                 </a:solidFill>
@@ -12508,7 +12580,7 @@
           <a:lstStyle/>
           <a:p>
             <a:pPr algn="ctr"/>
-            <a:endParaRPr/>
+            <a:endParaRPr sz="2400"/>
           </a:p>
         </p:txBody>
       </p:sp>
@@ -12521,22 +12593,22 @@
         <p:spPr>
           <a:xfrm>
             <a:off x="6035040" y="1938528"/>
-            <a:ext cx="2788920" cy="713232"/>
-          </a:xfrm>
-          <a:prstGeom prst="rect">
-            <a:avLst/>
-          </a:prstGeom>
-          <a:noFill/>
-        </p:spPr>
-        <p:txBody>
-          <a:bodyPr wrap="square">
-            <a:spAutoFit/>
-          </a:bodyPr>
-          <a:lstStyle/>
-          <a:p>
-            <a:pPr algn="ctr"/>
-            <a:r>
-              <a:rPr sz="3200" b="0" i="0">
+            <a:ext cx="2788920" cy="707886"/>
+          </a:xfrm>
+          <a:prstGeom prst="rect">
+            <a:avLst/>
+          </a:prstGeom>
+          <a:noFill/>
+        </p:spPr>
+        <p:txBody>
+          <a:bodyPr wrap="square">
+            <a:spAutoFit/>
+          </a:bodyPr>
+          <a:lstStyle/>
+          <a:p>
+            <a:pPr algn="ctr"/>
+            <a:r>
+              <a:rPr sz="4000" b="0" i="0">
                 <a:solidFill>
                   <a:srgbClr val="FFFFFF"/>
                 </a:solidFill>
@@ -12556,22 +12628,22 @@
         <p:spPr>
           <a:xfrm>
             <a:off x="6126480" y="2651760"/>
-            <a:ext cx="2606040" cy="457200"/>
-          </a:xfrm>
-          <a:prstGeom prst="rect">
-            <a:avLst/>
-          </a:prstGeom>
-          <a:noFill/>
-        </p:spPr>
-        <p:txBody>
-          <a:bodyPr wrap="square">
-            <a:spAutoFit/>
-          </a:bodyPr>
-          <a:lstStyle/>
-          <a:p>
-            <a:pPr algn="ctr"/>
-            <a:r>
-              <a:rPr sz="1600" b="1" i="0">
+            <a:ext cx="2606040" cy="400110"/>
+          </a:xfrm>
+          <a:prstGeom prst="rect">
+            <a:avLst/>
+          </a:prstGeom>
+          <a:noFill/>
+        </p:spPr>
+        <p:txBody>
+          <a:bodyPr wrap="square">
+            <a:spAutoFit/>
+          </a:bodyPr>
+          <a:lstStyle/>
+          <a:p>
+            <a:pPr algn="ctr"/>
+            <a:r>
+              <a:rPr sz="2000" b="1" i="0">
                 <a:solidFill>
                   <a:srgbClr val="F5A623"/>
                 </a:solidFill>
@@ -12622,7 +12694,7 @@
           <a:lstStyle/>
           <a:p>
             <a:pPr algn="ctr"/>
-            <a:endParaRPr/>
+            <a:endParaRPr sz="2400"/>
           </a:p>
         </p:txBody>
       </p:sp>
@@ -12635,22 +12707,22 @@
         <p:spPr>
           <a:xfrm>
             <a:off x="6144768" y="3182112"/>
-            <a:ext cx="2569464" cy="1188720"/>
-          </a:xfrm>
-          <a:prstGeom prst="rect">
-            <a:avLst/>
-          </a:prstGeom>
-          <a:noFill/>
-        </p:spPr>
-        <p:txBody>
-          <a:bodyPr wrap="square">
-            <a:spAutoFit/>
-          </a:bodyPr>
-          <a:lstStyle/>
-          <a:p>
-            <a:pPr algn="ctr"/>
-            <a:r>
-              <a:rPr sz="1250" b="0" i="0">
+            <a:ext cx="2569464" cy="830997"/>
+          </a:xfrm>
+          <a:prstGeom prst="rect">
+            <a:avLst/>
+          </a:prstGeom>
+          <a:noFill/>
+        </p:spPr>
+        <p:txBody>
+          <a:bodyPr wrap="square">
+            <a:spAutoFit/>
+          </a:bodyPr>
+          <a:lstStyle/>
+          <a:p>
+            <a:pPr algn="ctr"/>
+            <a:r>
+              <a:rPr sz="1600" b="0" i="0">
                 <a:solidFill>
                   <a:srgbClr val="F5F5F0"/>
                 </a:solidFill>
@@ -12705,7 +12777,7 @@
           <a:lstStyle/>
           <a:p>
             <a:pPr algn="ctr"/>
-            <a:endParaRPr/>
+            <a:endParaRPr sz="2400"/>
           </a:p>
         </p:txBody>
       </p:sp>
@@ -12718,7 +12790,7 @@
         <p:spPr>
           <a:xfrm>
             <a:off x="6217920" y="4480560"/>
-            <a:ext cx="2423160" cy="1737360"/>
+            <a:ext cx="2423160" cy="1077218"/>
           </a:xfrm>
           <a:prstGeom prst="rect">
             <a:avLst/>
@@ -12733,7 +12805,7 @@
           <a:p>
             <a:pPr algn="l"/>
             <a:r>
-              <a:rPr sz="1150" b="0" i="0">
+              <a:rPr sz="1600" b="0" i="0">
                 <a:solidFill>
                   <a:srgbClr val="6FBF73"/>
                 </a:solidFill>
@@ -12788,7 +12860,7 @@
           <a:lstStyle/>
           <a:p>
             <a:pPr algn="ctr"/>
-            <a:endParaRPr/>
+            <a:endParaRPr sz="2400"/>
           </a:p>
         </p:txBody>
       </p:sp>
@@ -12801,22 +12873,22 @@
         <p:spPr>
           <a:xfrm>
             <a:off x="8915400" y="1938528"/>
-            <a:ext cx="2788920" cy="713232"/>
-          </a:xfrm>
-          <a:prstGeom prst="rect">
-            <a:avLst/>
-          </a:prstGeom>
-          <a:noFill/>
-        </p:spPr>
-        <p:txBody>
-          <a:bodyPr wrap="square">
-            <a:spAutoFit/>
-          </a:bodyPr>
-          <a:lstStyle/>
-          <a:p>
-            <a:pPr algn="ctr"/>
-            <a:r>
-              <a:rPr sz="3200" b="0" i="0">
+            <a:ext cx="2788920" cy="707886"/>
+          </a:xfrm>
+          <a:prstGeom prst="rect">
+            <a:avLst/>
+          </a:prstGeom>
+          <a:noFill/>
+        </p:spPr>
+        <p:txBody>
+          <a:bodyPr wrap="square">
+            <a:spAutoFit/>
+          </a:bodyPr>
+          <a:lstStyle/>
+          <a:p>
+            <a:pPr algn="ctr"/>
+            <a:r>
+              <a:rPr sz="4000" b="0" i="0">
                 <a:solidFill>
                   <a:srgbClr val="FFFFFF"/>
                 </a:solidFill>
@@ -12836,22 +12908,22 @@
         <p:spPr>
           <a:xfrm>
             <a:off x="9006840" y="2651760"/>
-            <a:ext cx="2606040" cy="457200"/>
-          </a:xfrm>
-          <a:prstGeom prst="rect">
-            <a:avLst/>
-          </a:prstGeom>
-          <a:noFill/>
-        </p:spPr>
-        <p:txBody>
-          <a:bodyPr wrap="square">
-            <a:spAutoFit/>
-          </a:bodyPr>
-          <a:lstStyle/>
-          <a:p>
-            <a:pPr algn="ctr"/>
-            <a:r>
-              <a:rPr sz="1600" b="1" i="0">
+            <a:ext cx="2606040" cy="400110"/>
+          </a:xfrm>
+          <a:prstGeom prst="rect">
+            <a:avLst/>
+          </a:prstGeom>
+          <a:noFill/>
+        </p:spPr>
+        <p:txBody>
+          <a:bodyPr wrap="square">
+            <a:spAutoFit/>
+          </a:bodyPr>
+          <a:lstStyle/>
+          <a:p>
+            <a:pPr algn="ctr"/>
+            <a:r>
+              <a:rPr sz="2000" b="1" i="0">
                 <a:solidFill>
                   <a:srgbClr val="F5A623"/>
                 </a:solidFill>
@@ -12902,7 +12974,7 @@
           <a:lstStyle/>
           <a:p>
             <a:pPr algn="ctr"/>
-            <a:endParaRPr/>
+            <a:endParaRPr sz="2400"/>
           </a:p>
         </p:txBody>
       </p:sp>
@@ -12915,22 +12987,22 @@
         <p:spPr>
           <a:xfrm>
             <a:off x="9025128" y="3182112"/>
-            <a:ext cx="2569464" cy="1188720"/>
-          </a:xfrm>
-          <a:prstGeom prst="rect">
-            <a:avLst/>
-          </a:prstGeom>
-          <a:noFill/>
-        </p:spPr>
-        <p:txBody>
-          <a:bodyPr wrap="square">
-            <a:spAutoFit/>
-          </a:bodyPr>
-          <a:lstStyle/>
-          <a:p>
-            <a:pPr algn="ctr"/>
-            <a:r>
-              <a:rPr sz="1250" b="0" i="0">
+            <a:ext cx="2569464" cy="830997"/>
+          </a:xfrm>
+          <a:prstGeom prst="rect">
+            <a:avLst/>
+          </a:prstGeom>
+          <a:noFill/>
+        </p:spPr>
+        <p:txBody>
+          <a:bodyPr wrap="square">
+            <a:spAutoFit/>
+          </a:bodyPr>
+          <a:lstStyle/>
+          <a:p>
+            <a:pPr algn="ctr"/>
+            <a:r>
+              <a:rPr sz="1600" b="0" i="0">
                 <a:solidFill>
                   <a:srgbClr val="F5F5F0"/>
                 </a:solidFill>
@@ -12985,7 +13057,7 @@
           <a:lstStyle/>
           <a:p>
             <a:pPr algn="ctr"/>
-            <a:endParaRPr/>
+            <a:endParaRPr sz="2400"/>
           </a:p>
         </p:txBody>
       </p:sp>
@@ -12998,7 +13070,7 @@
         <p:spPr>
           <a:xfrm>
             <a:off x="9098280" y="4480560"/>
-            <a:ext cx="2423160" cy="1737360"/>
+            <a:ext cx="2423160" cy="1323439"/>
           </a:xfrm>
           <a:prstGeom prst="rect">
             <a:avLst/>
@@ -13013,7 +13085,7 @@
           <a:p>
             <a:pPr algn="l"/>
             <a:r>
-              <a:rPr sz="1150" b="0" i="0">
+              <a:rPr sz="1600" b="0" i="0">
                 <a:solidFill>
                   <a:srgbClr val="6FBF73"/>
                 </a:solidFill>
@@ -19886,7 +19958,7 @@
             <a:avLst/>
           </a:prstGeom>
           <a:solidFill>
-            <a:srgbClr val="F5F5F0"/>
+            <a:srgbClr val="0D1F14"/>
           </a:solidFill>
           <a:ln>
             <a:noFill/>
@@ -19911,13 +19983,55 @@
           <a:lstStyle/>
           <a:p>
             <a:pPr algn="ctr"/>
-            <a:endParaRPr sz="2400"/>
           </a:p>
         </p:txBody>
       </p:sp>
       <p:sp>
         <p:nvSpPr>
           <p:cNvPr id="3" name="Rectangle 2"/>
+          <p:cNvSpPr/>
+          <p:nvPr/>
+        </p:nvSpPr>
+        <p:spPr>
+          <a:xfrm>
+            <a:off x="0" y="0"/>
+            <a:ext cx="12188952" cy="64008"/>
+          </a:xfrm>
+          <a:prstGeom prst="rect">
+            <a:avLst/>
+          </a:prstGeom>
+          <a:solidFill>
+            <a:srgbClr val="6FBF73"/>
+          </a:solidFill>
+          <a:ln>
+            <a:noFill/>
+          </a:ln>
+        </p:spPr>
+        <p:style>
+          <a:lnRef idx="1">
+            <a:schemeClr val="accent1"/>
+          </a:lnRef>
+          <a:fillRef idx="3">
+            <a:schemeClr val="accent1"/>
+          </a:fillRef>
+          <a:effectRef idx="2">
+            <a:schemeClr val="accent1"/>
+          </a:effectRef>
+          <a:fontRef idx="minor">
+            <a:schemeClr val="lt1"/>
+          </a:fontRef>
+        </p:style>
+        <p:txBody>
+          <a:bodyPr rtlCol="0" anchor="ctr"/>
+          <a:lstStyle/>
+          <a:p>
+            <a:pPr algn="ctr"/>
+          </a:p>
+        </p:txBody>
+      </p:sp>
+      <p:sp>
+        <p:nvSpPr>
+          <p:cNvPr id="4" name="Rectangle 3"/>
           <p:cNvSpPr/>
           <p:nvPr/>
         </p:nvSpPr>
@@ -19955,13 +20069,12 @@
           <a:lstStyle/>
           <a:p>
             <a:pPr algn="ctr"/>
-            <a:endParaRPr sz="2400"/>
-          </a:p>
-        </p:txBody>
-      </p:sp>
-      <p:sp>
-        <p:nvSpPr>
-          <p:cNvPr id="4" name="Rectangle 3"/>
+          </a:p>
+        </p:txBody>
+      </p:sp>
+      <p:sp>
+        <p:nvSpPr>
+          <p:cNvPr id="5" name="Rectangle 4"/>
           <p:cNvSpPr/>
           <p:nvPr/>
         </p:nvSpPr>
@@ -19999,20 +20112,19 @@
           <a:lstStyle/>
           <a:p>
             <a:pPr algn="ctr"/>
-            <a:endParaRPr sz="2400"/>
-          </a:p>
-        </p:txBody>
-      </p:sp>
-      <p:sp>
-        <p:nvSpPr>
-          <p:cNvPr id="5" name="TextBox 4"/>
-          <p:cNvSpPr txBox="1"/>
-          <p:nvPr/>
-        </p:nvSpPr>
-        <p:spPr>
-          <a:xfrm>
-            <a:off x="365760" y="274320"/>
-            <a:ext cx="11430000" cy="646331"/>
+          </a:p>
+        </p:txBody>
+      </p:sp>
+      <p:sp>
+        <p:nvSpPr>
+          <p:cNvPr id="6" name="TextBox 5"/>
+          <p:cNvSpPr txBox="1"/>
+          <p:nvPr/>
+        </p:nvSpPr>
+        <p:spPr>
+          <a:xfrm>
+            <a:off x="365760" y="256032"/>
+            <a:ext cx="11430000" cy="731520"/>
           </a:xfrm>
           <a:prstGeom prst="rect">
             <a:avLst/>
@@ -20027,79 +20139,31 @@
           <a:p>
             <a:pPr algn="l"/>
             <a:r>
-              <a:rPr sz="3600" b="1" i="0">
+              <a:rPr sz="2800" b="1" i="0">
                 <a:solidFill>
                   <a:srgbClr val="FFFFFF"/>
                 </a:solidFill>
                 <a:latin typeface="Calibri"/>
               </a:rPr>
-              <a:t>📋  Agenda Materi Kuliah</a:t>
-            </a:r>
-          </a:p>
-        </p:txBody>
-      </p:sp>
-      <p:sp>
-        <p:nvSpPr>
-          <p:cNvPr id="6" name="Rounded Rectangle 5"/>
+              <a:t>📋  Agenda Materi Kuliah — IoT untuk Peternakan 2026</a:t>
+            </a:r>
+          </a:p>
+        </p:txBody>
+      </p:sp>
+      <p:sp>
+        <p:nvSpPr>
+          <p:cNvPr id="7" name="Rounded Rectangle 6"/>
           <p:cNvSpPr/>
           <p:nvPr/>
         </p:nvSpPr>
         <p:spPr>
           <a:xfrm>
-            <a:off x="320040" y="1371600"/>
-            <a:ext cx="5623560" cy="1170432"/>
+            <a:off x="274320" y="1371600"/>
+            <a:ext cx="3931920" cy="1417320"/>
           </a:xfrm>
           <a:prstGeom prst="roundRect">
             <a:avLst>
-              <a:gd name="adj" fmla="val 4000"/>
-            </a:avLst>
-          </a:prstGeom>
-          <a:solidFill>
-            <a:srgbClr val="FFFFFF"/>
-          </a:solidFill>
-          <a:ln w="19050">
-            <a:solidFill>
-              <a:srgbClr val="6FBF73"/>
-            </a:solidFill>
-          </a:ln>
-        </p:spPr>
-        <p:style>
-          <a:lnRef idx="1">
-            <a:schemeClr val="accent1"/>
-          </a:lnRef>
-          <a:fillRef idx="3">
-            <a:schemeClr val="accent1"/>
-          </a:fillRef>
-          <a:effectRef idx="2">
-            <a:schemeClr val="accent1"/>
-          </a:effectRef>
-          <a:fontRef idx="minor">
-            <a:schemeClr val="lt1"/>
-          </a:fontRef>
-        </p:style>
-        <p:txBody>
-          <a:bodyPr rtlCol="0" anchor="ctr"/>
-          <a:lstStyle/>
-          <a:p>
-            <a:pPr algn="ctr"/>
-            <a:endParaRPr sz="2400"/>
-          </a:p>
-        </p:txBody>
-      </p:sp>
-      <p:sp>
-        <p:nvSpPr>
-          <p:cNvPr id="7" name="Rounded Rectangle 6"/>
-          <p:cNvSpPr/>
-          <p:nvPr/>
-        </p:nvSpPr>
-        <p:spPr>
-          <a:xfrm>
-            <a:off x="457200" y="1691640"/>
-            <a:ext cx="475488" cy="475488"/>
-          </a:xfrm>
-          <a:prstGeom prst="roundRect">
-            <a:avLst>
-              <a:gd name="adj" fmla="val 10000"/>
+              <a:gd name="adj" fmla="val 5000"/>
             </a:avLst>
           </a:prstGeom>
           <a:solidFill>
@@ -20128,156 +20192,30 @@
           <a:lstStyle/>
           <a:p>
             <a:pPr algn="ctr"/>
-            <a:endParaRPr sz="2400"/>
-          </a:p>
-        </p:txBody>
-      </p:sp>
-      <p:sp>
-        <p:nvSpPr>
-          <p:cNvPr id="8" name="TextBox 7"/>
-          <p:cNvSpPr txBox="1"/>
-          <p:nvPr/>
-        </p:nvSpPr>
-        <p:spPr>
-          <a:xfrm>
-            <a:off x="457200" y="1691640"/>
-            <a:ext cx="475488" cy="369332"/>
-          </a:xfrm>
-          <a:prstGeom prst="rect">
-            <a:avLst/>
-          </a:prstGeom>
-          <a:noFill/>
-        </p:spPr>
-        <p:txBody>
-          <a:bodyPr wrap="square">
-            <a:spAutoFit/>
-          </a:bodyPr>
-          <a:lstStyle/>
-          <a:p>
-            <a:pPr algn="ctr"/>
-            <a:r>
-              <a:rPr b="1" i="0">
-                <a:solidFill>
-                  <a:srgbClr val="FFFFFF"/>
-                </a:solidFill>
-                <a:latin typeface="Calibri"/>
-              </a:rPr>
-              <a:t>01</a:t>
-            </a:r>
-          </a:p>
-        </p:txBody>
-      </p:sp>
-      <p:sp>
-        <p:nvSpPr>
-          <p:cNvPr id="9" name="TextBox 8"/>
-          <p:cNvSpPr txBox="1"/>
-          <p:nvPr/>
-        </p:nvSpPr>
-        <p:spPr>
-          <a:xfrm>
-            <a:off x="1051560" y="1508760"/>
-            <a:ext cx="4754880" cy="400110"/>
-          </a:xfrm>
-          <a:prstGeom prst="rect">
-            <a:avLst/>
-          </a:prstGeom>
-          <a:noFill/>
-        </p:spPr>
-        <p:txBody>
-          <a:bodyPr wrap="square">
-            <a:spAutoFit/>
-          </a:bodyPr>
-          <a:lstStyle/>
-          <a:p>
-            <a:pPr algn="l"/>
-            <a:r>
-              <a:rPr sz="2000" b="1" i="0" dirty="0">
-                <a:solidFill>
-                  <a:srgbClr val="1B562E"/>
-                </a:solidFill>
-                <a:latin typeface="Segoe UI Emoji"/>
-              </a:rPr>
-              <a:t>🛡️  </a:t>
-            </a:r>
-            <a:r>
-              <a:rPr sz="2000" b="1" i="0" dirty="0" err="1">
-                <a:solidFill>
-                  <a:srgbClr val="1B562E"/>
-                </a:solidFill>
-                <a:latin typeface="Segoe UI Emoji"/>
-              </a:rPr>
-              <a:t>Mitos</a:t>
-            </a:r>
-            <a:r>
-              <a:rPr sz="2000" b="1" i="0" dirty="0">
-                <a:solidFill>
-                  <a:srgbClr val="1B562E"/>
-                </a:solidFill>
-                <a:latin typeface="Segoe UI Emoji"/>
-              </a:rPr>
-              <a:t> vs Fakta IoT</a:t>
-            </a:r>
-          </a:p>
-        </p:txBody>
-      </p:sp>
-      <p:sp>
-        <p:nvSpPr>
-          <p:cNvPr id="10" name="TextBox 9"/>
-          <p:cNvSpPr txBox="1"/>
-          <p:nvPr/>
-        </p:nvSpPr>
-        <p:spPr>
-          <a:xfrm>
-            <a:off x="1051560" y="2029968"/>
-            <a:ext cx="4754880" cy="338554"/>
-          </a:xfrm>
-          <a:prstGeom prst="rect">
-            <a:avLst/>
-          </a:prstGeom>
-          <a:noFill/>
-        </p:spPr>
-        <p:txBody>
-          <a:bodyPr wrap="square">
-            <a:spAutoFit/>
-          </a:bodyPr>
-          <a:lstStyle/>
-          <a:p>
-            <a:pPr algn="l"/>
-            <a:r>
-              <a:rPr sz="1600" b="0" i="0">
-                <a:solidFill>
-                  <a:srgbClr val="444444"/>
-                </a:solidFill>
-                <a:latin typeface="Calibri"/>
-              </a:rPr>
-              <a:t>Kenapa anak peternakan tidak usah takut IT</a:t>
-            </a:r>
-          </a:p>
-        </p:txBody>
-      </p:sp>
-      <p:sp>
-        <p:nvSpPr>
-          <p:cNvPr id="11" name="Rounded Rectangle 10"/>
+          </a:p>
+        </p:txBody>
+      </p:sp>
+      <p:sp>
+        <p:nvSpPr>
+          <p:cNvPr id="8" name="Rounded Rectangle 7"/>
           <p:cNvSpPr/>
           <p:nvPr/>
         </p:nvSpPr>
         <p:spPr>
           <a:xfrm>
-            <a:off x="320040" y="2670048"/>
-            <a:ext cx="5623560" cy="1170432"/>
+            <a:off x="384048" y="1481328"/>
+            <a:ext cx="411480" cy="411480"/>
           </a:xfrm>
           <a:prstGeom prst="roundRect">
             <a:avLst>
-              <a:gd name="adj" fmla="val 4000"/>
+              <a:gd name="adj" fmla="val 50000"/>
             </a:avLst>
           </a:prstGeom>
           <a:solidFill>
-            <a:srgbClr val="FFFFFF"/>
+            <a:srgbClr val="6FBF73"/>
           </a:solidFill>
-          <a:ln w="19050">
-            <a:solidFill>
-              <a:srgbClr val="6FBF73"/>
-            </a:solidFill>
+          <a:ln>
+            <a:noFill/>
           </a:ln>
         </p:spPr>
         <p:style>
@@ -20299,24 +20237,164 @@
           <a:lstStyle/>
           <a:p>
             <a:pPr algn="ctr"/>
-            <a:endParaRPr sz="2400"/>
-          </a:p>
-        </p:txBody>
-      </p:sp>
-      <p:sp>
-        <p:nvSpPr>
-          <p:cNvPr id="12" name="Rounded Rectangle 11"/>
+          </a:p>
+        </p:txBody>
+      </p:sp>
+      <p:sp>
+        <p:nvSpPr>
+          <p:cNvPr id="9" name="TextBox 8"/>
+          <p:cNvSpPr txBox="1"/>
+          <p:nvPr/>
+        </p:nvSpPr>
+        <p:spPr>
+          <a:xfrm>
+            <a:off x="384048" y="1508760"/>
+            <a:ext cx="411480" cy="347472"/>
+          </a:xfrm>
+          <a:prstGeom prst="rect">
+            <a:avLst/>
+          </a:prstGeom>
+          <a:noFill/>
+        </p:spPr>
+        <p:txBody>
+          <a:bodyPr wrap="square">
+            <a:spAutoFit/>
+          </a:bodyPr>
+          <a:lstStyle/>
+          <a:p>
+            <a:pPr algn="ctr"/>
+            <a:r>
+              <a:rPr sz="1400" b="1" i="0">
+                <a:solidFill>
+                  <a:srgbClr val="0D1F14"/>
+                </a:solidFill>
+                <a:latin typeface="Calibri"/>
+              </a:rPr>
+              <a:t>01</a:t>
+            </a:r>
+          </a:p>
+        </p:txBody>
+      </p:sp>
+      <p:sp>
+        <p:nvSpPr>
+          <p:cNvPr id="10" name="TextBox 9"/>
+          <p:cNvSpPr txBox="1"/>
+          <p:nvPr/>
+        </p:nvSpPr>
+        <p:spPr>
+          <a:xfrm>
+            <a:off x="3639312" y="1463040"/>
+            <a:ext cx="457200" cy="457200"/>
+          </a:xfrm>
+          <a:prstGeom prst="rect">
+            <a:avLst/>
+          </a:prstGeom>
+          <a:noFill/>
+        </p:spPr>
+        <p:txBody>
+          <a:bodyPr wrap="square">
+            <a:spAutoFit/>
+          </a:bodyPr>
+          <a:lstStyle/>
+          <a:p>
+            <a:pPr algn="l"/>
+            <a:r>
+              <a:rPr sz="2400" b="0" i="0">
+                <a:solidFill>
+                  <a:srgbClr val="FFFFFF"/>
+                </a:solidFill>
+                <a:latin typeface="Segoe UI Emoji"/>
+              </a:rPr>
+              <a:t>🛡️</a:t>
+            </a:r>
+          </a:p>
+        </p:txBody>
+      </p:sp>
+      <p:sp>
+        <p:nvSpPr>
+          <p:cNvPr id="11" name="TextBox 10"/>
+          <p:cNvSpPr txBox="1"/>
+          <p:nvPr/>
+        </p:nvSpPr>
+        <p:spPr>
+          <a:xfrm>
+            <a:off x="868680" y="1499616"/>
+            <a:ext cx="3200400" cy="411480"/>
+          </a:xfrm>
+          <a:prstGeom prst="rect">
+            <a:avLst/>
+          </a:prstGeom>
+          <a:noFill/>
+        </p:spPr>
+        <p:txBody>
+          <a:bodyPr wrap="square">
+            <a:spAutoFit/>
+          </a:bodyPr>
+          <a:lstStyle/>
+          <a:p>
+            <a:pPr algn="l"/>
+            <a:r>
+              <a:rPr sz="1600" b="1" i="0">
+                <a:solidFill>
+                  <a:srgbClr val="FFFFFF"/>
+                </a:solidFill>
+                <a:latin typeface="Calibri"/>
+              </a:rPr>
+              <a:t>Mitos vs Fakta</a:t>
+            </a:r>
+          </a:p>
+        </p:txBody>
+      </p:sp>
+      <p:sp>
+        <p:nvSpPr>
+          <p:cNvPr id="12" name="TextBox 11"/>
+          <p:cNvSpPr txBox="1"/>
+          <p:nvPr/>
+        </p:nvSpPr>
+        <p:spPr>
+          <a:xfrm>
+            <a:off x="868680" y="1938528"/>
+            <a:ext cx="3200400" cy="685800"/>
+          </a:xfrm>
+          <a:prstGeom prst="rect">
+            <a:avLst/>
+          </a:prstGeom>
+          <a:noFill/>
+        </p:spPr>
+        <p:txBody>
+          <a:bodyPr wrap="square">
+            <a:spAutoFit/>
+          </a:bodyPr>
+          <a:lstStyle/>
+          <a:p>
+            <a:pPr algn="l"/>
+            <a:r>
+              <a:rPr sz="1250" b="0" i="0">
+                <a:solidFill>
+                  <a:srgbClr val="F5F5F0"/>
+                </a:solidFill>
+                <a:latin typeface="Calibri"/>
+              </a:rPr>
+              <a:t>Mahasiswa Fapet
+harus bisa coding?</a:t>
+            </a:r>
+          </a:p>
+        </p:txBody>
+      </p:sp>
+      <p:sp>
+        <p:nvSpPr>
+          <p:cNvPr id="13" name="Rounded Rectangle 12"/>
           <p:cNvSpPr/>
           <p:nvPr/>
         </p:nvSpPr>
         <p:spPr>
           <a:xfrm>
-            <a:off x="457200" y="2990088"/>
-            <a:ext cx="475488" cy="475488"/>
+            <a:off x="4306824" y="1371600"/>
+            <a:ext cx="3931920" cy="1417320"/>
           </a:xfrm>
           <a:prstGeom prst="roundRect">
             <a:avLst>
-              <a:gd name="adj" fmla="val 10000"/>
+              <a:gd name="adj" fmla="val 5000"/>
             </a:avLst>
           </a:prstGeom>
           <a:solidFill>
@@ -20345,138 +20423,30 @@
           <a:lstStyle/>
           <a:p>
             <a:pPr algn="ctr"/>
-            <a:endParaRPr sz="2400"/>
-          </a:p>
-        </p:txBody>
-      </p:sp>
-      <p:sp>
-        <p:nvSpPr>
-          <p:cNvPr id="13" name="TextBox 12"/>
-          <p:cNvSpPr txBox="1"/>
-          <p:nvPr/>
-        </p:nvSpPr>
-        <p:spPr>
-          <a:xfrm>
-            <a:off x="457200" y="2990088"/>
-            <a:ext cx="475488" cy="369332"/>
-          </a:xfrm>
-          <a:prstGeom prst="rect">
-            <a:avLst/>
-          </a:prstGeom>
-          <a:noFill/>
-        </p:spPr>
-        <p:txBody>
-          <a:bodyPr wrap="square">
-            <a:spAutoFit/>
-          </a:bodyPr>
-          <a:lstStyle/>
-          <a:p>
-            <a:pPr algn="ctr"/>
-            <a:r>
-              <a:rPr b="1" i="0">
-                <a:solidFill>
-                  <a:srgbClr val="FFFFFF"/>
-                </a:solidFill>
-                <a:latin typeface="Calibri"/>
-              </a:rPr>
-              <a:t>02</a:t>
-            </a:r>
-          </a:p>
-        </p:txBody>
-      </p:sp>
-      <p:sp>
-        <p:nvSpPr>
-          <p:cNvPr id="14" name="TextBox 13"/>
-          <p:cNvSpPr txBox="1"/>
-          <p:nvPr/>
-        </p:nvSpPr>
-        <p:spPr>
-          <a:xfrm>
-            <a:off x="1051560" y="2807208"/>
-            <a:ext cx="4754880" cy="400110"/>
-          </a:xfrm>
-          <a:prstGeom prst="rect">
-            <a:avLst/>
-          </a:prstGeom>
-          <a:noFill/>
-        </p:spPr>
-        <p:txBody>
-          <a:bodyPr wrap="square">
-            <a:spAutoFit/>
-          </a:bodyPr>
-          <a:lstStyle/>
-          <a:p>
-            <a:pPr algn="l"/>
-            <a:r>
-              <a:rPr sz="2000" b="1" i="0">
-                <a:solidFill>
-                  <a:srgbClr val="1B562E"/>
-                </a:solidFill>
-                <a:latin typeface="Segoe UI Emoji"/>
-              </a:rPr>
-              <a:t>🤔  Apa &amp; Bagaimana IoT?</a:t>
-            </a:r>
-          </a:p>
-        </p:txBody>
-      </p:sp>
-      <p:sp>
-        <p:nvSpPr>
-          <p:cNvPr id="15" name="TextBox 14"/>
-          <p:cNvSpPr txBox="1"/>
-          <p:nvPr/>
-        </p:nvSpPr>
-        <p:spPr>
-          <a:xfrm>
-            <a:off x="1051560" y="3328416"/>
-            <a:ext cx="4754880" cy="338554"/>
-          </a:xfrm>
-          <a:prstGeom prst="rect">
-            <a:avLst/>
-          </a:prstGeom>
-          <a:noFill/>
-        </p:spPr>
-        <p:txBody>
-          <a:bodyPr wrap="square">
-            <a:spAutoFit/>
-          </a:bodyPr>
-          <a:lstStyle/>
-          <a:p>
-            <a:pPr algn="l"/>
-            <a:r>
-              <a:rPr sz="1600" b="0" i="0">
-                <a:solidFill>
-                  <a:srgbClr val="444444"/>
-                </a:solidFill>
-                <a:latin typeface="Calibri"/>
-              </a:rPr>
-              <a:t>Konsep paling dasar &amp; cara kerjanya</a:t>
-            </a:r>
-          </a:p>
-        </p:txBody>
-      </p:sp>
-      <p:sp>
-        <p:nvSpPr>
-          <p:cNvPr id="16" name="Rounded Rectangle 15"/>
+          </a:p>
+        </p:txBody>
+      </p:sp>
+      <p:sp>
+        <p:nvSpPr>
+          <p:cNvPr id="14" name="Rounded Rectangle 13"/>
           <p:cNvSpPr/>
           <p:nvPr/>
         </p:nvSpPr>
         <p:spPr>
           <a:xfrm>
-            <a:off x="320040" y="3968496"/>
-            <a:ext cx="5623560" cy="1170432"/>
+            <a:off x="4416552" y="1481328"/>
+            <a:ext cx="411480" cy="411480"/>
           </a:xfrm>
           <a:prstGeom prst="roundRect">
             <a:avLst>
-              <a:gd name="adj" fmla="val 4000"/>
+              <a:gd name="adj" fmla="val 50000"/>
             </a:avLst>
           </a:prstGeom>
           <a:solidFill>
-            <a:srgbClr val="FFFFFF"/>
+            <a:srgbClr val="6FBF73"/>
           </a:solidFill>
-          <a:ln w="19050">
-            <a:solidFill>
-              <a:srgbClr val="6FBF73"/>
-            </a:solidFill>
+          <a:ln>
+            <a:noFill/>
           </a:ln>
         </p:spPr>
         <p:style>
@@ -20498,24 +20468,164 @@
           <a:lstStyle/>
           <a:p>
             <a:pPr algn="ctr"/>
-            <a:endParaRPr sz="2400"/>
-          </a:p>
-        </p:txBody>
-      </p:sp>
-      <p:sp>
-        <p:nvSpPr>
-          <p:cNvPr id="17" name="Rounded Rectangle 16"/>
+          </a:p>
+        </p:txBody>
+      </p:sp>
+      <p:sp>
+        <p:nvSpPr>
+          <p:cNvPr id="15" name="TextBox 14"/>
+          <p:cNvSpPr txBox="1"/>
+          <p:nvPr/>
+        </p:nvSpPr>
+        <p:spPr>
+          <a:xfrm>
+            <a:off x="4416552" y="1508760"/>
+            <a:ext cx="411480" cy="347472"/>
+          </a:xfrm>
+          <a:prstGeom prst="rect">
+            <a:avLst/>
+          </a:prstGeom>
+          <a:noFill/>
+        </p:spPr>
+        <p:txBody>
+          <a:bodyPr wrap="square">
+            <a:spAutoFit/>
+          </a:bodyPr>
+          <a:lstStyle/>
+          <a:p>
+            <a:pPr algn="ctr"/>
+            <a:r>
+              <a:rPr sz="1400" b="1" i="0">
+                <a:solidFill>
+                  <a:srgbClr val="0D1F14"/>
+                </a:solidFill>
+                <a:latin typeface="Calibri"/>
+              </a:rPr>
+              <a:t>02</a:t>
+            </a:r>
+          </a:p>
+        </p:txBody>
+      </p:sp>
+      <p:sp>
+        <p:nvSpPr>
+          <p:cNvPr id="16" name="TextBox 15"/>
+          <p:cNvSpPr txBox="1"/>
+          <p:nvPr/>
+        </p:nvSpPr>
+        <p:spPr>
+          <a:xfrm>
+            <a:off x="7671816" y="1463040"/>
+            <a:ext cx="457200" cy="457200"/>
+          </a:xfrm>
+          <a:prstGeom prst="rect">
+            <a:avLst/>
+          </a:prstGeom>
+          <a:noFill/>
+        </p:spPr>
+        <p:txBody>
+          <a:bodyPr wrap="square">
+            <a:spAutoFit/>
+          </a:bodyPr>
+          <a:lstStyle/>
+          <a:p>
+            <a:pPr algn="l"/>
+            <a:r>
+              <a:rPr sz="2400" b="0" i="0">
+                <a:solidFill>
+                  <a:srgbClr val="FFFFFF"/>
+                </a:solidFill>
+                <a:latin typeface="Segoe UI Emoji"/>
+              </a:rPr>
+              <a:t>🤔</a:t>
+            </a:r>
+          </a:p>
+        </p:txBody>
+      </p:sp>
+      <p:sp>
+        <p:nvSpPr>
+          <p:cNvPr id="17" name="TextBox 16"/>
+          <p:cNvSpPr txBox="1"/>
+          <p:nvPr/>
+        </p:nvSpPr>
+        <p:spPr>
+          <a:xfrm>
+            <a:off x="4901184" y="1499616"/>
+            <a:ext cx="3200400" cy="411480"/>
+          </a:xfrm>
+          <a:prstGeom prst="rect">
+            <a:avLst/>
+          </a:prstGeom>
+          <a:noFill/>
+        </p:spPr>
+        <p:txBody>
+          <a:bodyPr wrap="square">
+            <a:spAutoFit/>
+          </a:bodyPr>
+          <a:lstStyle/>
+          <a:p>
+            <a:pPr algn="l"/>
+            <a:r>
+              <a:rPr sz="1600" b="1" i="0">
+                <a:solidFill>
+                  <a:srgbClr val="FFFFFF"/>
+                </a:solidFill>
+                <a:latin typeface="Calibri"/>
+              </a:rPr>
+              <a:t>Apa itu IoT?</a:t>
+            </a:r>
+          </a:p>
+        </p:txBody>
+      </p:sp>
+      <p:sp>
+        <p:nvSpPr>
+          <p:cNvPr id="18" name="TextBox 17"/>
+          <p:cNvSpPr txBox="1"/>
+          <p:nvPr/>
+        </p:nvSpPr>
+        <p:spPr>
+          <a:xfrm>
+            <a:off x="4901184" y="1938528"/>
+            <a:ext cx="3200400" cy="685800"/>
+          </a:xfrm>
+          <a:prstGeom prst="rect">
+            <a:avLst/>
+          </a:prstGeom>
+          <a:noFill/>
+        </p:spPr>
+        <p:txBody>
+          <a:bodyPr wrap="square">
+            <a:spAutoFit/>
+          </a:bodyPr>
+          <a:lstStyle/>
+          <a:p>
+            <a:pPr algn="l"/>
+            <a:r>
+              <a:rPr sz="1250" b="0" i="0">
+                <a:solidFill>
+                  <a:srgbClr val="F5F5F0"/>
+                </a:solidFill>
+                <a:latin typeface="Calibri"/>
+              </a:rPr>
+              <a:t>Sensor → Cloud
+→ HP kamu</a:t>
+            </a:r>
+          </a:p>
+        </p:txBody>
+      </p:sp>
+      <p:sp>
+        <p:nvSpPr>
+          <p:cNvPr id="19" name="Rounded Rectangle 18"/>
           <p:cNvSpPr/>
           <p:nvPr/>
         </p:nvSpPr>
         <p:spPr>
           <a:xfrm>
-            <a:off x="457200" y="4288536"/>
-            <a:ext cx="475488" cy="475488"/>
+            <a:off x="8339328" y="1371600"/>
+            <a:ext cx="3931920" cy="1417320"/>
           </a:xfrm>
           <a:prstGeom prst="roundRect">
             <a:avLst>
-              <a:gd name="adj" fmla="val 10000"/>
+              <a:gd name="adj" fmla="val 5000"/>
             </a:avLst>
           </a:prstGeom>
           <a:solidFill>
@@ -20544,138 +20654,30 @@
           <a:lstStyle/>
           <a:p>
             <a:pPr algn="ctr"/>
-            <a:endParaRPr sz="2400"/>
-          </a:p>
-        </p:txBody>
-      </p:sp>
-      <p:sp>
-        <p:nvSpPr>
-          <p:cNvPr id="18" name="TextBox 17"/>
-          <p:cNvSpPr txBox="1"/>
-          <p:nvPr/>
-        </p:nvSpPr>
-        <p:spPr>
-          <a:xfrm>
-            <a:off x="457200" y="4288536"/>
-            <a:ext cx="475488" cy="369332"/>
-          </a:xfrm>
-          <a:prstGeom prst="rect">
-            <a:avLst/>
-          </a:prstGeom>
-          <a:noFill/>
-        </p:spPr>
-        <p:txBody>
-          <a:bodyPr wrap="square">
-            <a:spAutoFit/>
-          </a:bodyPr>
-          <a:lstStyle/>
-          <a:p>
-            <a:pPr algn="ctr"/>
-            <a:r>
-              <a:rPr b="1" i="0">
-                <a:solidFill>
-                  <a:srgbClr val="FFFFFF"/>
-                </a:solidFill>
-                <a:latin typeface="Calibri"/>
-              </a:rPr>
-              <a:t>03</a:t>
-            </a:r>
-          </a:p>
-        </p:txBody>
-      </p:sp>
-      <p:sp>
-        <p:nvSpPr>
-          <p:cNvPr id="19" name="TextBox 18"/>
-          <p:cNvSpPr txBox="1"/>
-          <p:nvPr/>
-        </p:nvSpPr>
-        <p:spPr>
-          <a:xfrm>
-            <a:off x="1051560" y="4105656"/>
-            <a:ext cx="4754880" cy="400110"/>
-          </a:xfrm>
-          <a:prstGeom prst="rect">
-            <a:avLst/>
-          </a:prstGeom>
-          <a:noFill/>
-        </p:spPr>
-        <p:txBody>
-          <a:bodyPr wrap="square">
-            <a:spAutoFit/>
-          </a:bodyPr>
-          <a:lstStyle/>
-          <a:p>
-            <a:pPr algn="l"/>
-            <a:r>
-              <a:rPr sz="2000" b="1" i="0">
-                <a:solidFill>
-                  <a:srgbClr val="1B562E"/>
-                </a:solidFill>
-                <a:latin typeface="Segoe UI Emoji"/>
-              </a:rPr>
-              <a:t>🌟  IoT di Sekitar Kita</a:t>
-            </a:r>
-          </a:p>
-        </p:txBody>
-      </p:sp>
-      <p:sp>
-        <p:nvSpPr>
-          <p:cNvPr id="20" name="TextBox 19"/>
-          <p:cNvSpPr txBox="1"/>
-          <p:nvPr/>
-        </p:nvSpPr>
-        <p:spPr>
-          <a:xfrm>
-            <a:off x="1051560" y="4626864"/>
-            <a:ext cx="4754880" cy="338554"/>
-          </a:xfrm>
-          <a:prstGeom prst="rect">
-            <a:avLst/>
-          </a:prstGeom>
-          <a:noFill/>
-        </p:spPr>
-        <p:txBody>
-          <a:bodyPr wrap="square">
-            <a:spAutoFit/>
-          </a:bodyPr>
-          <a:lstStyle/>
-          <a:p>
-            <a:pPr algn="l"/>
-            <a:r>
-              <a:rPr sz="1600" b="0" i="0">
-                <a:solidFill>
-                  <a:srgbClr val="444444"/>
-                </a:solidFill>
-                <a:latin typeface="Calibri"/>
-              </a:rPr>
-              <a:t>Contoh teknologi yang sudah kita pakai</a:t>
-            </a:r>
-          </a:p>
-        </p:txBody>
-      </p:sp>
-      <p:sp>
-        <p:nvSpPr>
-          <p:cNvPr id="21" name="Rounded Rectangle 20"/>
+          </a:p>
+        </p:txBody>
+      </p:sp>
+      <p:sp>
+        <p:nvSpPr>
+          <p:cNvPr id="20" name="Rounded Rectangle 19"/>
           <p:cNvSpPr/>
           <p:nvPr/>
         </p:nvSpPr>
         <p:spPr>
           <a:xfrm>
-            <a:off x="320040" y="5266944"/>
-            <a:ext cx="5623560" cy="1170432"/>
+            <a:off x="8449056" y="1481328"/>
+            <a:ext cx="411480" cy="411480"/>
           </a:xfrm>
           <a:prstGeom prst="roundRect">
             <a:avLst>
-              <a:gd name="adj" fmla="val 4000"/>
+              <a:gd name="adj" fmla="val 50000"/>
             </a:avLst>
           </a:prstGeom>
           <a:solidFill>
-            <a:srgbClr val="FFFFFF"/>
+            <a:srgbClr val="6FBF73"/>
           </a:solidFill>
-          <a:ln w="19050">
-            <a:solidFill>
-              <a:srgbClr val="6FBF73"/>
-            </a:solidFill>
+          <a:ln>
+            <a:noFill/>
           </a:ln>
         </p:spPr>
         <p:style>
@@ -20697,24 +20699,164 @@
           <a:lstStyle/>
           <a:p>
             <a:pPr algn="ctr"/>
-            <a:endParaRPr sz="2400"/>
-          </a:p>
-        </p:txBody>
-      </p:sp>
-      <p:sp>
-        <p:nvSpPr>
-          <p:cNvPr id="22" name="Rounded Rectangle 21"/>
+          </a:p>
+        </p:txBody>
+      </p:sp>
+      <p:sp>
+        <p:nvSpPr>
+          <p:cNvPr id="21" name="TextBox 20"/>
+          <p:cNvSpPr txBox="1"/>
+          <p:nvPr/>
+        </p:nvSpPr>
+        <p:spPr>
+          <a:xfrm>
+            <a:off x="8449056" y="1508760"/>
+            <a:ext cx="411480" cy="347472"/>
+          </a:xfrm>
+          <a:prstGeom prst="rect">
+            <a:avLst/>
+          </a:prstGeom>
+          <a:noFill/>
+        </p:spPr>
+        <p:txBody>
+          <a:bodyPr wrap="square">
+            <a:spAutoFit/>
+          </a:bodyPr>
+          <a:lstStyle/>
+          <a:p>
+            <a:pPr algn="ctr"/>
+            <a:r>
+              <a:rPr sz="1400" b="1" i="0">
+                <a:solidFill>
+                  <a:srgbClr val="0D1F14"/>
+                </a:solidFill>
+                <a:latin typeface="Calibri"/>
+              </a:rPr>
+              <a:t>03</a:t>
+            </a:r>
+          </a:p>
+        </p:txBody>
+      </p:sp>
+      <p:sp>
+        <p:nvSpPr>
+          <p:cNvPr id="22" name="TextBox 21"/>
+          <p:cNvSpPr txBox="1"/>
+          <p:nvPr/>
+        </p:nvSpPr>
+        <p:spPr>
+          <a:xfrm>
+            <a:off x="11704320" y="1463040"/>
+            <a:ext cx="457200" cy="457200"/>
+          </a:xfrm>
+          <a:prstGeom prst="rect">
+            <a:avLst/>
+          </a:prstGeom>
+          <a:noFill/>
+        </p:spPr>
+        <p:txBody>
+          <a:bodyPr wrap="square">
+            <a:spAutoFit/>
+          </a:bodyPr>
+          <a:lstStyle/>
+          <a:p>
+            <a:pPr algn="l"/>
+            <a:r>
+              <a:rPr sz="2400" b="0" i="0">
+                <a:solidFill>
+                  <a:srgbClr val="FFFFFF"/>
+                </a:solidFill>
+                <a:latin typeface="Segoe UI Emoji"/>
+              </a:rPr>
+              <a:t>🐄</a:t>
+            </a:r>
+          </a:p>
+        </p:txBody>
+      </p:sp>
+      <p:sp>
+        <p:nvSpPr>
+          <p:cNvPr id="23" name="TextBox 22"/>
+          <p:cNvSpPr txBox="1"/>
+          <p:nvPr/>
+        </p:nvSpPr>
+        <p:spPr>
+          <a:xfrm>
+            <a:off x="8933688" y="1499616"/>
+            <a:ext cx="3200400" cy="411480"/>
+          </a:xfrm>
+          <a:prstGeom prst="rect">
+            <a:avLst/>
+          </a:prstGeom>
+          <a:noFill/>
+        </p:spPr>
+        <p:txBody>
+          <a:bodyPr wrap="square">
+            <a:spAutoFit/>
+          </a:bodyPr>
+          <a:lstStyle/>
+          <a:p>
+            <a:pPr algn="l"/>
+            <a:r>
+              <a:rPr sz="1600" b="1" i="0">
+                <a:solidFill>
+                  <a:srgbClr val="FFFFFF"/>
+                </a:solidFill>
+                <a:latin typeface="Calibri"/>
+              </a:rPr>
+              <a:t>IoT di Peternakan</a:t>
+            </a:r>
+          </a:p>
+        </p:txBody>
+      </p:sp>
+      <p:sp>
+        <p:nvSpPr>
+          <p:cNvPr id="24" name="TextBox 23"/>
+          <p:cNvSpPr txBox="1"/>
+          <p:nvPr/>
+        </p:nvSpPr>
+        <p:spPr>
+          <a:xfrm>
+            <a:off x="8933688" y="1938528"/>
+            <a:ext cx="3200400" cy="685800"/>
+          </a:xfrm>
+          <a:prstGeom prst="rect">
+            <a:avLst/>
+          </a:prstGeom>
+          <a:noFill/>
+        </p:spPr>
+        <p:txBody>
+          <a:bodyPr wrap="square">
+            <a:spAutoFit/>
+          </a:bodyPr>
+          <a:lstStyle/>
+          <a:p>
+            <a:pPr algn="l"/>
+            <a:r>
+              <a:rPr sz="1250" b="0" i="0">
+                <a:solidFill>
+                  <a:srgbClr val="F5F5F0"/>
+                </a:solidFill>
+                <a:latin typeface="Calibri"/>
+              </a:rPr>
+              <a:t>6 aplikasi nyata
+di kandang</a:t>
+            </a:r>
+          </a:p>
+        </p:txBody>
+      </p:sp>
+      <p:sp>
+        <p:nvSpPr>
+          <p:cNvPr id="25" name="Rounded Rectangle 24"/>
           <p:cNvSpPr/>
           <p:nvPr/>
         </p:nvSpPr>
         <p:spPr>
           <a:xfrm>
-            <a:off x="457200" y="5586984"/>
-            <a:ext cx="475488" cy="475488"/>
+            <a:off x="274320" y="2898648"/>
+            <a:ext cx="3931920" cy="1417320"/>
           </a:xfrm>
           <a:prstGeom prst="roundRect">
             <a:avLst>
-              <a:gd name="adj" fmla="val 10000"/>
+              <a:gd name="adj" fmla="val 5000"/>
             </a:avLst>
           </a:prstGeom>
           <a:solidFill>
@@ -20743,112 +20885,6 @@
           <a:lstStyle/>
           <a:p>
             <a:pPr algn="ctr"/>
-            <a:endParaRPr sz="2400"/>
-          </a:p>
-        </p:txBody>
-      </p:sp>
-      <p:sp>
-        <p:nvSpPr>
-          <p:cNvPr id="23" name="TextBox 22"/>
-          <p:cNvSpPr txBox="1"/>
-          <p:nvPr/>
-        </p:nvSpPr>
-        <p:spPr>
-          <a:xfrm>
-            <a:off x="457200" y="5586984"/>
-            <a:ext cx="475488" cy="369332"/>
-          </a:xfrm>
-          <a:prstGeom prst="rect">
-            <a:avLst/>
-          </a:prstGeom>
-          <a:noFill/>
-        </p:spPr>
-        <p:txBody>
-          <a:bodyPr wrap="square">
-            <a:spAutoFit/>
-          </a:bodyPr>
-          <a:lstStyle/>
-          <a:p>
-            <a:pPr algn="ctr"/>
-            <a:r>
-              <a:rPr b="1" i="0">
-                <a:solidFill>
-                  <a:srgbClr val="FFFFFF"/>
-                </a:solidFill>
-                <a:latin typeface="Calibri"/>
-              </a:rPr>
-              <a:t>04</a:t>
-            </a:r>
-          </a:p>
-        </p:txBody>
-      </p:sp>
-      <p:sp>
-        <p:nvSpPr>
-          <p:cNvPr id="24" name="TextBox 23"/>
-          <p:cNvSpPr txBox="1"/>
-          <p:nvPr/>
-        </p:nvSpPr>
-        <p:spPr>
-          <a:xfrm>
-            <a:off x="1051560" y="5404104"/>
-            <a:ext cx="4754880" cy="400110"/>
-          </a:xfrm>
-          <a:prstGeom prst="rect">
-            <a:avLst/>
-          </a:prstGeom>
-          <a:noFill/>
-        </p:spPr>
-        <p:txBody>
-          <a:bodyPr wrap="square">
-            <a:spAutoFit/>
-          </a:bodyPr>
-          <a:lstStyle/>
-          <a:p>
-            <a:pPr algn="l"/>
-            <a:r>
-              <a:rPr sz="2000" b="1" i="0">
-                <a:solidFill>
-                  <a:srgbClr val="1B562E"/>
-                </a:solidFill>
-                <a:latin typeface="Segoe UI Emoji"/>
-              </a:rPr>
-              <a:t>⚖️  Tradisional vs Smart Farm</a:t>
-            </a:r>
-          </a:p>
-        </p:txBody>
-      </p:sp>
-      <p:sp>
-        <p:nvSpPr>
-          <p:cNvPr id="25" name="TextBox 24"/>
-          <p:cNvSpPr txBox="1"/>
-          <p:nvPr/>
-        </p:nvSpPr>
-        <p:spPr>
-          <a:xfrm>
-            <a:off x="1051560" y="5925312"/>
-            <a:ext cx="4754880" cy="338554"/>
-          </a:xfrm>
-          <a:prstGeom prst="rect">
-            <a:avLst/>
-          </a:prstGeom>
-          <a:noFill/>
-        </p:spPr>
-        <p:txBody>
-          <a:bodyPr wrap="square">
-            <a:spAutoFit/>
-          </a:bodyPr>
-          <a:lstStyle/>
-          <a:p>
-            <a:pPr algn="l"/>
-            <a:r>
-              <a:rPr sz="1600" b="0" i="0">
-                <a:solidFill>
-                  <a:srgbClr val="444444"/>
-                </a:solidFill>
-                <a:latin typeface="Calibri"/>
-              </a:rPr>
-              <a:t>Perbandingan efisiensi kerja kandang</a:t>
-            </a:r>
           </a:p>
         </p:txBody>
       </p:sp>
@@ -20860,21 +20896,19 @@
         </p:nvSpPr>
         <p:spPr>
           <a:xfrm>
-            <a:off x="6172200" y="1371600"/>
-            <a:ext cx="5623560" cy="1170432"/>
+            <a:off x="384048" y="3008376"/>
+            <a:ext cx="411480" cy="411480"/>
           </a:xfrm>
           <a:prstGeom prst="roundRect">
             <a:avLst>
-              <a:gd name="adj" fmla="val 4000"/>
+              <a:gd name="adj" fmla="val 50000"/>
             </a:avLst>
           </a:prstGeom>
           <a:solidFill>
-            <a:srgbClr val="FFFFFF"/>
+            <a:srgbClr val="6FBF73"/>
           </a:solidFill>
-          <a:ln w="19050">
-            <a:solidFill>
-              <a:srgbClr val="6FBF73"/>
-            </a:solidFill>
+          <a:ln>
+            <a:noFill/>
           </a:ln>
         </p:spPr>
         <p:style>
@@ -20896,24 +20930,164 @@
           <a:lstStyle/>
           <a:p>
             <a:pPr algn="ctr"/>
-            <a:endParaRPr sz="2400"/>
-          </a:p>
-        </p:txBody>
-      </p:sp>
-      <p:sp>
-        <p:nvSpPr>
-          <p:cNvPr id="27" name="Rounded Rectangle 26"/>
+          </a:p>
+        </p:txBody>
+      </p:sp>
+      <p:sp>
+        <p:nvSpPr>
+          <p:cNvPr id="27" name="TextBox 26"/>
+          <p:cNvSpPr txBox="1"/>
+          <p:nvPr/>
+        </p:nvSpPr>
+        <p:spPr>
+          <a:xfrm>
+            <a:off x="384048" y="3035808"/>
+            <a:ext cx="411480" cy="347472"/>
+          </a:xfrm>
+          <a:prstGeom prst="rect">
+            <a:avLst/>
+          </a:prstGeom>
+          <a:noFill/>
+        </p:spPr>
+        <p:txBody>
+          <a:bodyPr wrap="square">
+            <a:spAutoFit/>
+          </a:bodyPr>
+          <a:lstStyle/>
+          <a:p>
+            <a:pPr algn="ctr"/>
+            <a:r>
+              <a:rPr sz="1400" b="1" i="0">
+                <a:solidFill>
+                  <a:srgbClr val="0D1F14"/>
+                </a:solidFill>
+                <a:latin typeface="Calibri"/>
+              </a:rPr>
+              <a:t>04</a:t>
+            </a:r>
+          </a:p>
+        </p:txBody>
+      </p:sp>
+      <p:sp>
+        <p:nvSpPr>
+          <p:cNvPr id="28" name="TextBox 27"/>
+          <p:cNvSpPr txBox="1"/>
+          <p:nvPr/>
+        </p:nvSpPr>
+        <p:spPr>
+          <a:xfrm>
+            <a:off x="3639312" y="2990088"/>
+            <a:ext cx="457200" cy="457200"/>
+          </a:xfrm>
+          <a:prstGeom prst="rect">
+            <a:avLst/>
+          </a:prstGeom>
+          <a:noFill/>
+        </p:spPr>
+        <p:txBody>
+          <a:bodyPr wrap="square">
+            <a:spAutoFit/>
+          </a:bodyPr>
+          <a:lstStyle/>
+          <a:p>
+            <a:pPr algn="l"/>
+            <a:r>
+              <a:rPr sz="2400" b="0" i="0">
+                <a:solidFill>
+                  <a:srgbClr val="FFFFFF"/>
+                </a:solidFill>
+                <a:latin typeface="Segoe UI Emoji"/>
+              </a:rPr>
+              <a:t>🗺️</a:t>
+            </a:r>
+          </a:p>
+        </p:txBody>
+      </p:sp>
+      <p:sp>
+        <p:nvSpPr>
+          <p:cNvPr id="29" name="TextBox 28"/>
+          <p:cNvSpPr txBox="1"/>
+          <p:nvPr/>
+        </p:nvSpPr>
+        <p:spPr>
+          <a:xfrm>
+            <a:off x="868680" y="3026664"/>
+            <a:ext cx="3200400" cy="411480"/>
+          </a:xfrm>
+          <a:prstGeom prst="rect">
+            <a:avLst/>
+          </a:prstGeom>
+          <a:noFill/>
+        </p:spPr>
+        <p:txBody>
+          <a:bodyPr wrap="square">
+            <a:spAutoFit/>
+          </a:bodyPr>
+          <a:lstStyle/>
+          <a:p>
+            <a:pPr algn="l"/>
+            <a:r>
+              <a:rPr sz="1600" b="1" i="0">
+                <a:solidFill>
+                  <a:srgbClr val="FFFFFF"/>
+                </a:solidFill>
+                <a:latin typeface="Calibri"/>
+              </a:rPr>
+              <a:t>Studi Kasus Kaltim</a:t>
+            </a:r>
+          </a:p>
+        </p:txBody>
+      </p:sp>
+      <p:sp>
+        <p:nvSpPr>
+          <p:cNvPr id="30" name="TextBox 29"/>
+          <p:cNvSpPr txBox="1"/>
+          <p:nvPr/>
+        </p:nvSpPr>
+        <p:spPr>
+          <a:xfrm>
+            <a:off x="868680" y="3465576"/>
+            <a:ext cx="3200400" cy="685800"/>
+          </a:xfrm>
+          <a:prstGeom prst="rect">
+            <a:avLst/>
+          </a:prstGeom>
+          <a:noFill/>
+        </p:spPr>
+        <p:txBody>
+          <a:bodyPr wrap="square">
+            <a:spAutoFit/>
+          </a:bodyPr>
+          <a:lstStyle/>
+          <a:p>
+            <a:pPr algn="l"/>
+            <a:r>
+              <a:rPr sz="1250" b="0" i="0">
+                <a:solidFill>
+                  <a:srgbClr val="F5F5F0"/>
+                </a:solidFill>
+                <a:latin typeface="Calibri"/>
+              </a:rPr>
+              <a:t>SISKA, GPS Collar
+Sapi Bali</a:t>
+            </a:r>
+          </a:p>
+        </p:txBody>
+      </p:sp>
+      <p:sp>
+        <p:nvSpPr>
+          <p:cNvPr id="31" name="Rounded Rectangle 30"/>
           <p:cNvSpPr/>
           <p:nvPr/>
         </p:nvSpPr>
         <p:spPr>
           <a:xfrm>
-            <a:off x="6309360" y="1691640"/>
-            <a:ext cx="475488" cy="475488"/>
+            <a:off x="4306824" y="2898648"/>
+            <a:ext cx="3931920" cy="1417320"/>
           </a:xfrm>
           <a:prstGeom prst="roundRect">
             <a:avLst>
-              <a:gd name="adj" fmla="val 10000"/>
+              <a:gd name="adj" fmla="val 5000"/>
             </a:avLst>
           </a:prstGeom>
           <a:solidFill>
@@ -20942,138 +21116,30 @@
           <a:lstStyle/>
           <a:p>
             <a:pPr algn="ctr"/>
-            <a:endParaRPr sz="2400"/>
-          </a:p>
-        </p:txBody>
-      </p:sp>
-      <p:sp>
-        <p:nvSpPr>
-          <p:cNvPr id="28" name="TextBox 27"/>
-          <p:cNvSpPr txBox="1"/>
-          <p:nvPr/>
-        </p:nvSpPr>
-        <p:spPr>
-          <a:xfrm>
-            <a:off x="6309360" y="1691640"/>
-            <a:ext cx="475488" cy="369332"/>
-          </a:xfrm>
-          <a:prstGeom prst="rect">
-            <a:avLst/>
-          </a:prstGeom>
-          <a:noFill/>
-        </p:spPr>
-        <p:txBody>
-          <a:bodyPr wrap="square">
-            <a:spAutoFit/>
-          </a:bodyPr>
-          <a:lstStyle/>
-          <a:p>
-            <a:pPr algn="ctr"/>
-            <a:r>
-              <a:rPr b="1" i="0">
-                <a:solidFill>
-                  <a:srgbClr val="FFFFFF"/>
-                </a:solidFill>
-                <a:latin typeface="Calibri"/>
-              </a:rPr>
-              <a:t>05</a:t>
-            </a:r>
-          </a:p>
-        </p:txBody>
-      </p:sp>
-      <p:sp>
-        <p:nvSpPr>
-          <p:cNvPr id="29" name="TextBox 28"/>
-          <p:cNvSpPr txBox="1"/>
-          <p:nvPr/>
-        </p:nvSpPr>
-        <p:spPr>
-          <a:xfrm>
-            <a:off x="6903720" y="1508760"/>
-            <a:ext cx="4754880" cy="400110"/>
-          </a:xfrm>
-          <a:prstGeom prst="rect">
-            <a:avLst/>
-          </a:prstGeom>
-          <a:noFill/>
-        </p:spPr>
-        <p:txBody>
-          <a:bodyPr wrap="square">
-            <a:spAutoFit/>
-          </a:bodyPr>
-          <a:lstStyle/>
-          <a:p>
-            <a:pPr algn="l"/>
-            <a:r>
-              <a:rPr sz="2000" b="1" i="0">
-                <a:solidFill>
-                  <a:srgbClr val="1B562E"/>
-                </a:solidFill>
-                <a:latin typeface="Segoe UI Emoji"/>
-              </a:rPr>
-              <a:t>🐄  6 Aplikasi di Kandang</a:t>
-            </a:r>
-          </a:p>
-        </p:txBody>
-      </p:sp>
-      <p:sp>
-        <p:nvSpPr>
-          <p:cNvPr id="30" name="TextBox 29"/>
-          <p:cNvSpPr txBox="1"/>
-          <p:nvPr/>
-        </p:nvSpPr>
-        <p:spPr>
-          <a:xfrm>
-            <a:off x="6903720" y="2029968"/>
-            <a:ext cx="4754880" cy="338554"/>
-          </a:xfrm>
-          <a:prstGeom prst="rect">
-            <a:avLst/>
-          </a:prstGeom>
-          <a:noFill/>
-        </p:spPr>
-        <p:txBody>
-          <a:bodyPr wrap="square">
-            <a:spAutoFit/>
-          </a:bodyPr>
-          <a:lstStyle/>
-          <a:p>
-            <a:pPr algn="l"/>
-            <a:r>
-              <a:rPr sz="1600" b="0" i="0">
-                <a:solidFill>
-                  <a:srgbClr val="444444"/>
-                </a:solidFill>
-                <a:latin typeface="Calibri"/>
-              </a:rPr>
-              <a:t>Penerapan nyata sensor pada ternak</a:t>
-            </a:r>
-          </a:p>
-        </p:txBody>
-      </p:sp>
-      <p:sp>
-        <p:nvSpPr>
-          <p:cNvPr id="31" name="Rounded Rectangle 30"/>
+          </a:p>
+        </p:txBody>
+      </p:sp>
+      <p:sp>
+        <p:nvSpPr>
+          <p:cNvPr id="32" name="Rounded Rectangle 31"/>
           <p:cNvSpPr/>
           <p:nvPr/>
         </p:nvSpPr>
         <p:spPr>
           <a:xfrm>
-            <a:off x="6172200" y="2670048"/>
-            <a:ext cx="5623560" cy="1170432"/>
+            <a:off x="4416552" y="3008376"/>
+            <a:ext cx="411480" cy="411480"/>
           </a:xfrm>
           <a:prstGeom prst="roundRect">
             <a:avLst>
-              <a:gd name="adj" fmla="val 4000"/>
+              <a:gd name="adj" fmla="val 50000"/>
             </a:avLst>
           </a:prstGeom>
           <a:solidFill>
-            <a:srgbClr val="FFFFFF"/>
+            <a:srgbClr val="6FBF73"/>
           </a:solidFill>
-          <a:ln w="19050">
-            <a:solidFill>
-              <a:srgbClr val="6FBF73"/>
-            </a:solidFill>
+          <a:ln>
+            <a:noFill/>
           </a:ln>
         </p:spPr>
         <p:style>
@@ -21095,24 +21161,164 @@
           <a:lstStyle/>
           <a:p>
             <a:pPr algn="ctr"/>
-            <a:endParaRPr sz="2400"/>
-          </a:p>
-        </p:txBody>
-      </p:sp>
-      <p:sp>
-        <p:nvSpPr>
-          <p:cNvPr id="32" name="Rounded Rectangle 31"/>
+          </a:p>
+        </p:txBody>
+      </p:sp>
+      <p:sp>
+        <p:nvSpPr>
+          <p:cNvPr id="33" name="TextBox 32"/>
+          <p:cNvSpPr txBox="1"/>
+          <p:nvPr/>
+        </p:nvSpPr>
+        <p:spPr>
+          <a:xfrm>
+            <a:off x="4416552" y="3035808"/>
+            <a:ext cx="411480" cy="347472"/>
+          </a:xfrm>
+          <a:prstGeom prst="rect">
+            <a:avLst/>
+          </a:prstGeom>
+          <a:noFill/>
+        </p:spPr>
+        <p:txBody>
+          <a:bodyPr wrap="square">
+            <a:spAutoFit/>
+          </a:bodyPr>
+          <a:lstStyle/>
+          <a:p>
+            <a:pPr algn="ctr"/>
+            <a:r>
+              <a:rPr sz="1400" b="1" i="0">
+                <a:solidFill>
+                  <a:srgbClr val="0D1F14"/>
+                </a:solidFill>
+                <a:latin typeface="Calibri"/>
+              </a:rPr>
+              <a:t>05</a:t>
+            </a:r>
+          </a:p>
+        </p:txBody>
+      </p:sp>
+      <p:sp>
+        <p:nvSpPr>
+          <p:cNvPr id="34" name="TextBox 33"/>
+          <p:cNvSpPr txBox="1"/>
+          <p:nvPr/>
+        </p:nvSpPr>
+        <p:spPr>
+          <a:xfrm>
+            <a:off x="7671816" y="2990088"/>
+            <a:ext cx="457200" cy="457200"/>
+          </a:xfrm>
+          <a:prstGeom prst="rect">
+            <a:avLst/>
+          </a:prstGeom>
+          <a:noFill/>
+        </p:spPr>
+        <p:txBody>
+          <a:bodyPr wrap="square">
+            <a:spAutoFit/>
+          </a:bodyPr>
+          <a:lstStyle/>
+          <a:p>
+            <a:pPr algn="l"/>
+            <a:r>
+              <a:rPr sz="2400" b="0" i="0">
+                <a:solidFill>
+                  <a:srgbClr val="FFFFFF"/>
+                </a:solidFill>
+                <a:latin typeface="Segoe UI Emoji"/>
+              </a:rPr>
+              <a:t>🎯</a:t>
+            </a:r>
+          </a:p>
+        </p:txBody>
+      </p:sp>
+      <p:sp>
+        <p:nvSpPr>
+          <p:cNvPr id="35" name="TextBox 34"/>
+          <p:cNvSpPr txBox="1"/>
+          <p:nvPr/>
+        </p:nvSpPr>
+        <p:spPr>
+          <a:xfrm>
+            <a:off x="4901184" y="3026664"/>
+            <a:ext cx="3200400" cy="411480"/>
+          </a:xfrm>
+          <a:prstGeom prst="rect">
+            <a:avLst/>
+          </a:prstGeom>
+          <a:noFill/>
+        </p:spPr>
+        <p:txBody>
+          <a:bodyPr wrap="square">
+            <a:spAutoFit/>
+          </a:bodyPr>
+          <a:lstStyle/>
+          <a:p>
+            <a:pPr algn="l"/>
+            <a:r>
+              <a:rPr sz="1600" b="1" i="0">
+                <a:solidFill>
+                  <a:srgbClr val="FFFFFF"/>
+                </a:solidFill>
+                <a:latin typeface="Calibri"/>
+              </a:rPr>
+              <a:t>Kuis Interaktif</a:t>
+            </a:r>
+          </a:p>
+        </p:txBody>
+      </p:sp>
+      <p:sp>
+        <p:nvSpPr>
+          <p:cNvPr id="36" name="TextBox 35"/>
+          <p:cNvSpPr txBox="1"/>
+          <p:nvPr/>
+        </p:nvSpPr>
+        <p:spPr>
+          <a:xfrm>
+            <a:off x="4901184" y="3465576"/>
+            <a:ext cx="3200400" cy="685800"/>
+          </a:xfrm>
+          <a:prstGeom prst="rect">
+            <a:avLst/>
+          </a:prstGeom>
+          <a:noFill/>
+        </p:spPr>
+        <p:txBody>
+          <a:bodyPr wrap="square">
+            <a:spAutoFit/>
+          </a:bodyPr>
+          <a:lstStyle/>
+          <a:p>
+            <a:pPr algn="l"/>
+            <a:r>
+              <a:rPr sz="1250" b="0" i="0">
+                <a:solidFill>
+                  <a:srgbClr val="F5F5F0"/>
+                </a:solidFill>
+                <a:latin typeface="Calibri"/>
+              </a:rPr>
+              <a:t>Tebak yang pakai
+IoT vs bukan</a:t>
+            </a:r>
+          </a:p>
+        </p:txBody>
+      </p:sp>
+      <p:sp>
+        <p:nvSpPr>
+          <p:cNvPr id="37" name="Rounded Rectangle 36"/>
           <p:cNvSpPr/>
           <p:nvPr/>
         </p:nvSpPr>
         <p:spPr>
           <a:xfrm>
-            <a:off x="6309360" y="2990088"/>
-            <a:ext cx="475488" cy="475488"/>
+            <a:off x="8339328" y="2898648"/>
+            <a:ext cx="3931920" cy="1417320"/>
           </a:xfrm>
           <a:prstGeom prst="roundRect">
             <a:avLst>
-              <a:gd name="adj" fmla="val 10000"/>
+              <a:gd name="adj" fmla="val 5000"/>
             </a:avLst>
           </a:prstGeom>
           <a:solidFill>
@@ -21141,138 +21347,30 @@
           <a:lstStyle/>
           <a:p>
             <a:pPr algn="ctr"/>
-            <a:endParaRPr sz="2400"/>
-          </a:p>
-        </p:txBody>
-      </p:sp>
-      <p:sp>
-        <p:nvSpPr>
-          <p:cNvPr id="33" name="TextBox 32"/>
-          <p:cNvSpPr txBox="1"/>
-          <p:nvPr/>
-        </p:nvSpPr>
-        <p:spPr>
-          <a:xfrm>
-            <a:off x="6309360" y="2990088"/>
-            <a:ext cx="475488" cy="369332"/>
-          </a:xfrm>
-          <a:prstGeom prst="rect">
-            <a:avLst/>
-          </a:prstGeom>
-          <a:noFill/>
-        </p:spPr>
-        <p:txBody>
-          <a:bodyPr wrap="square">
-            <a:spAutoFit/>
-          </a:bodyPr>
-          <a:lstStyle/>
-          <a:p>
-            <a:pPr algn="ctr"/>
-            <a:r>
-              <a:rPr b="1" i="0">
-                <a:solidFill>
-                  <a:srgbClr val="FFFFFF"/>
-                </a:solidFill>
-                <a:latin typeface="Calibri"/>
-              </a:rPr>
-              <a:t>06</a:t>
-            </a:r>
-          </a:p>
-        </p:txBody>
-      </p:sp>
-      <p:sp>
-        <p:nvSpPr>
-          <p:cNvPr id="34" name="TextBox 33"/>
-          <p:cNvSpPr txBox="1"/>
-          <p:nvPr/>
-        </p:nvSpPr>
-        <p:spPr>
-          <a:xfrm>
-            <a:off x="6903720" y="2807208"/>
-            <a:ext cx="4754880" cy="400110"/>
-          </a:xfrm>
-          <a:prstGeom prst="rect">
-            <a:avLst/>
-          </a:prstGeom>
-          <a:noFill/>
-        </p:spPr>
-        <p:txBody>
-          <a:bodyPr wrap="square">
-            <a:spAutoFit/>
-          </a:bodyPr>
-          <a:lstStyle/>
-          <a:p>
-            <a:pPr algn="l"/>
-            <a:r>
-              <a:rPr sz="2000" b="1" i="0">
-                <a:solidFill>
-                  <a:srgbClr val="1B562E"/>
-                </a:solidFill>
-                <a:latin typeface="Segoe UI Emoji"/>
-              </a:rPr>
-              <a:t>🗺️  Studi Kasus Sapi Bali (SISKA)</a:t>
-            </a:r>
-          </a:p>
-        </p:txBody>
-      </p:sp>
-      <p:sp>
-        <p:nvSpPr>
-          <p:cNvPr id="35" name="TextBox 34"/>
-          <p:cNvSpPr txBox="1"/>
-          <p:nvPr/>
-        </p:nvSpPr>
-        <p:spPr>
-          <a:xfrm>
-            <a:off x="6903720" y="3328416"/>
-            <a:ext cx="4754880" cy="338554"/>
-          </a:xfrm>
-          <a:prstGeom prst="rect">
-            <a:avLst/>
-          </a:prstGeom>
-          <a:noFill/>
-        </p:spPr>
-        <p:txBody>
-          <a:bodyPr wrap="square">
-            <a:spAutoFit/>
-          </a:bodyPr>
-          <a:lstStyle/>
-          <a:p>
-            <a:pPr algn="l"/>
-            <a:r>
-              <a:rPr sz="1600" b="0" i="0">
-                <a:solidFill>
-                  <a:srgbClr val="444444"/>
-                </a:solidFill>
-                <a:latin typeface="Calibri"/>
-              </a:rPr>
-              <a:t>Penerapan lokal di perkebunan sawit Kaltim</a:t>
-            </a:r>
-          </a:p>
-        </p:txBody>
-      </p:sp>
-      <p:sp>
-        <p:nvSpPr>
-          <p:cNvPr id="36" name="Rounded Rectangle 35"/>
+          </a:p>
+        </p:txBody>
+      </p:sp>
+      <p:sp>
+        <p:nvSpPr>
+          <p:cNvPr id="38" name="Rounded Rectangle 37"/>
           <p:cNvSpPr/>
           <p:nvPr/>
         </p:nvSpPr>
         <p:spPr>
           <a:xfrm>
-            <a:off x="6172200" y="3968496"/>
-            <a:ext cx="5623560" cy="1170432"/>
+            <a:off x="8449056" y="3008376"/>
+            <a:ext cx="411480" cy="411480"/>
           </a:xfrm>
           <a:prstGeom prst="roundRect">
             <a:avLst>
-              <a:gd name="adj" fmla="val 4000"/>
+              <a:gd name="adj" fmla="val 50000"/>
             </a:avLst>
           </a:prstGeom>
           <a:solidFill>
-            <a:srgbClr val="FFFFFF"/>
+            <a:srgbClr val="6FBF73"/>
           </a:solidFill>
-          <a:ln w="19050">
-            <a:solidFill>
-              <a:srgbClr val="6FBF73"/>
-            </a:solidFill>
+          <a:ln>
+            <a:noFill/>
           </a:ln>
         </p:spPr>
         <p:style>
@@ -21294,24 +21392,786 @@
           <a:lstStyle/>
           <a:p>
             <a:pPr algn="ctr"/>
-            <a:endParaRPr sz="2400"/>
-          </a:p>
-        </p:txBody>
-      </p:sp>
-      <p:sp>
-        <p:nvSpPr>
-          <p:cNvPr id="37" name="Rounded Rectangle 36"/>
+          </a:p>
+        </p:txBody>
+      </p:sp>
+      <p:sp>
+        <p:nvSpPr>
+          <p:cNvPr id="39" name="TextBox 38"/>
+          <p:cNvSpPr txBox="1"/>
+          <p:nvPr/>
+        </p:nvSpPr>
+        <p:spPr>
+          <a:xfrm>
+            <a:off x="8449056" y="3035808"/>
+            <a:ext cx="411480" cy="347472"/>
+          </a:xfrm>
+          <a:prstGeom prst="rect">
+            <a:avLst/>
+          </a:prstGeom>
+          <a:noFill/>
+        </p:spPr>
+        <p:txBody>
+          <a:bodyPr wrap="square">
+            <a:spAutoFit/>
+          </a:bodyPr>
+          <a:lstStyle/>
+          <a:p>
+            <a:pPr algn="ctr"/>
+            <a:r>
+              <a:rPr sz="1400" b="1" i="0">
+                <a:solidFill>
+                  <a:srgbClr val="0D1F14"/>
+                </a:solidFill>
+                <a:latin typeface="Calibri"/>
+              </a:rPr>
+              <a:t>06</a:t>
+            </a:r>
+          </a:p>
+        </p:txBody>
+      </p:sp>
+      <p:sp>
+        <p:nvSpPr>
+          <p:cNvPr id="40" name="TextBox 39"/>
+          <p:cNvSpPr txBox="1"/>
+          <p:nvPr/>
+        </p:nvSpPr>
+        <p:spPr>
+          <a:xfrm>
+            <a:off x="11704320" y="2990088"/>
+            <a:ext cx="457200" cy="457200"/>
+          </a:xfrm>
+          <a:prstGeom prst="rect">
+            <a:avLst/>
+          </a:prstGeom>
+          <a:noFill/>
+        </p:spPr>
+        <p:txBody>
+          <a:bodyPr wrap="square">
+            <a:spAutoFit/>
+          </a:bodyPr>
+          <a:lstStyle/>
+          <a:p>
+            <a:pPr algn="l"/>
+            <a:r>
+              <a:rPr sz="2400" b="0" i="0">
+                <a:solidFill>
+                  <a:srgbClr val="FFFFFF"/>
+                </a:solidFill>
+                <a:latin typeface="Segoe UI Emoji"/>
+              </a:rPr>
+              <a:t>🚀</a:t>
+            </a:r>
+          </a:p>
+        </p:txBody>
+      </p:sp>
+      <p:sp>
+        <p:nvSpPr>
+          <p:cNvPr id="41" name="TextBox 40"/>
+          <p:cNvSpPr txBox="1"/>
+          <p:nvPr/>
+        </p:nvSpPr>
+        <p:spPr>
+          <a:xfrm>
+            <a:off x="8933688" y="3026664"/>
+            <a:ext cx="3200400" cy="411480"/>
+          </a:xfrm>
+          <a:prstGeom prst="rect">
+            <a:avLst/>
+          </a:prstGeom>
+          <a:noFill/>
+        </p:spPr>
+        <p:txBody>
+          <a:bodyPr wrap="square">
+            <a:spAutoFit/>
+          </a:bodyPr>
+          <a:lstStyle/>
+          <a:p>
+            <a:pPr algn="l"/>
+            <a:r>
+              <a:rPr sz="1600" b="1" i="0">
+                <a:solidFill>
+                  <a:srgbClr val="FFFFFF"/>
+                </a:solidFill>
+                <a:latin typeface="Calibri"/>
+              </a:rPr>
+              <a:t>Peluang Karir</a:t>
+            </a:r>
+          </a:p>
+        </p:txBody>
+      </p:sp>
+      <p:sp>
+        <p:nvSpPr>
+          <p:cNvPr id="42" name="TextBox 41"/>
+          <p:cNvSpPr txBox="1"/>
+          <p:nvPr/>
+        </p:nvSpPr>
+        <p:spPr>
+          <a:xfrm>
+            <a:off x="8933688" y="3465576"/>
+            <a:ext cx="3200400" cy="685800"/>
+          </a:xfrm>
+          <a:prstGeom prst="rect">
+            <a:avLst/>
+          </a:prstGeom>
+          <a:noFill/>
+        </p:spPr>
+        <p:txBody>
+          <a:bodyPr wrap="square">
+            <a:spAutoFit/>
+          </a:bodyPr>
+          <a:lstStyle/>
+          <a:p>
+            <a:pPr algn="l"/>
+            <a:r>
+              <a:rPr sz="1250" b="0" i="0">
+                <a:solidFill>
+                  <a:srgbClr val="F5F5F0"/>
+                </a:solidFill>
+                <a:latin typeface="Calibri"/>
+              </a:rPr>
+              <a:t>Profesi baru
+lulusan Fapet</a:t>
+            </a:r>
+          </a:p>
+        </p:txBody>
+      </p:sp>
+      <p:sp>
+        <p:nvSpPr>
+          <p:cNvPr id="43" name="Rounded Rectangle 42"/>
           <p:cNvSpPr/>
           <p:nvPr/>
         </p:nvSpPr>
         <p:spPr>
           <a:xfrm>
-            <a:off x="6309360" y="4288536"/>
-            <a:ext cx="475488" cy="475488"/>
+            <a:off x="274320" y="4425696"/>
+            <a:ext cx="3931920" cy="1417320"/>
           </a:xfrm>
           <a:prstGeom prst="roundRect">
             <a:avLst>
-              <a:gd name="adj" fmla="val 10000"/>
+              <a:gd name="adj" fmla="val 5000"/>
+            </a:avLst>
+          </a:prstGeom>
+          <a:solidFill>
+            <a:srgbClr val="07578C"/>
+          </a:solidFill>
+          <a:ln>
+            <a:noFill/>
+          </a:ln>
+        </p:spPr>
+        <p:style>
+          <a:lnRef idx="1">
+            <a:schemeClr val="accent1"/>
+          </a:lnRef>
+          <a:fillRef idx="3">
+            <a:schemeClr val="accent1"/>
+          </a:fillRef>
+          <a:effectRef idx="2">
+            <a:schemeClr val="accent1"/>
+          </a:effectRef>
+          <a:fontRef idx="minor">
+            <a:schemeClr val="lt1"/>
+          </a:fontRef>
+        </p:style>
+        <p:txBody>
+          <a:bodyPr rtlCol="0" anchor="ctr"/>
+          <a:lstStyle/>
+          <a:p>
+            <a:pPr algn="ctr"/>
+          </a:p>
+        </p:txBody>
+      </p:sp>
+      <p:sp>
+        <p:nvSpPr>
+          <p:cNvPr id="44" name="Rounded Rectangle 43"/>
+          <p:cNvSpPr/>
+          <p:nvPr/>
+        </p:nvSpPr>
+        <p:spPr>
+          <a:xfrm>
+            <a:off x="384048" y="4535424"/>
+            <a:ext cx="411480" cy="411480"/>
+          </a:xfrm>
+          <a:prstGeom prst="roundRect">
+            <a:avLst>
+              <a:gd name="adj" fmla="val 50000"/>
+            </a:avLst>
+          </a:prstGeom>
+          <a:solidFill>
+            <a:srgbClr val="249EDA"/>
+          </a:solidFill>
+          <a:ln>
+            <a:noFill/>
+          </a:ln>
+        </p:spPr>
+        <p:style>
+          <a:lnRef idx="1">
+            <a:schemeClr val="accent1"/>
+          </a:lnRef>
+          <a:fillRef idx="3">
+            <a:schemeClr val="accent1"/>
+          </a:fillRef>
+          <a:effectRef idx="2">
+            <a:schemeClr val="accent1"/>
+          </a:effectRef>
+          <a:fontRef idx="minor">
+            <a:schemeClr val="lt1"/>
+          </a:fontRef>
+        </p:style>
+        <p:txBody>
+          <a:bodyPr rtlCol="0" anchor="ctr"/>
+          <a:lstStyle/>
+          <a:p>
+            <a:pPr algn="ctr"/>
+          </a:p>
+        </p:txBody>
+      </p:sp>
+      <p:sp>
+        <p:nvSpPr>
+          <p:cNvPr id="45" name="TextBox 44"/>
+          <p:cNvSpPr txBox="1"/>
+          <p:nvPr/>
+        </p:nvSpPr>
+        <p:spPr>
+          <a:xfrm>
+            <a:off x="384048" y="4562856"/>
+            <a:ext cx="411480" cy="347472"/>
+          </a:xfrm>
+          <a:prstGeom prst="rect">
+            <a:avLst/>
+          </a:prstGeom>
+          <a:noFill/>
+        </p:spPr>
+        <p:txBody>
+          <a:bodyPr wrap="square">
+            <a:spAutoFit/>
+          </a:bodyPr>
+          <a:lstStyle/>
+          <a:p>
+            <a:pPr algn="ctr"/>
+            <a:r>
+              <a:rPr sz="1400" b="1" i="0">
+                <a:solidFill>
+                  <a:srgbClr val="FFFFFF"/>
+                </a:solidFill>
+                <a:latin typeface="Calibri"/>
+              </a:rPr>
+              <a:t>07</a:t>
+            </a:r>
+          </a:p>
+        </p:txBody>
+      </p:sp>
+      <p:sp>
+        <p:nvSpPr>
+          <p:cNvPr id="46" name="TextBox 45"/>
+          <p:cNvSpPr txBox="1"/>
+          <p:nvPr/>
+        </p:nvSpPr>
+        <p:spPr>
+          <a:xfrm>
+            <a:off x="3639312" y="4517136"/>
+            <a:ext cx="457200" cy="457200"/>
+          </a:xfrm>
+          <a:prstGeom prst="rect">
+            <a:avLst/>
+          </a:prstGeom>
+          <a:noFill/>
+        </p:spPr>
+        <p:txBody>
+          <a:bodyPr wrap="square">
+            <a:spAutoFit/>
+          </a:bodyPr>
+          <a:lstStyle/>
+          <a:p>
+            <a:pPr algn="l"/>
+            <a:r>
+              <a:rPr sz="2400" b="0" i="0">
+                <a:solidFill>
+                  <a:srgbClr val="FFFFFF"/>
+                </a:solidFill>
+                <a:latin typeface="Segoe UI Emoji"/>
+              </a:rPr>
+              <a:t>📱</a:t>
+            </a:r>
+          </a:p>
+        </p:txBody>
+      </p:sp>
+      <p:sp>
+        <p:nvSpPr>
+          <p:cNvPr id="47" name="TextBox 46"/>
+          <p:cNvSpPr txBox="1"/>
+          <p:nvPr/>
+        </p:nvSpPr>
+        <p:spPr>
+          <a:xfrm>
+            <a:off x="868680" y="4553712"/>
+            <a:ext cx="3200400" cy="411480"/>
+          </a:xfrm>
+          <a:prstGeom prst="rect">
+            <a:avLst/>
+          </a:prstGeom>
+          <a:noFill/>
+        </p:spPr>
+        <p:txBody>
+          <a:bodyPr wrap="square">
+            <a:spAutoFit/>
+          </a:bodyPr>
+          <a:lstStyle/>
+          <a:p>
+            <a:pPr algn="l"/>
+            <a:r>
+              <a:rPr sz="1600" b="1" i="0">
+                <a:solidFill>
+                  <a:srgbClr val="249EDA"/>
+                </a:solidFill>
+                <a:latin typeface="Calibri"/>
+              </a:rPr>
+              <a:t>Telegram Bot</a:t>
+            </a:r>
+          </a:p>
+        </p:txBody>
+      </p:sp>
+      <p:sp>
+        <p:nvSpPr>
+          <p:cNvPr id="48" name="TextBox 47"/>
+          <p:cNvSpPr txBox="1"/>
+          <p:nvPr/>
+        </p:nvSpPr>
+        <p:spPr>
+          <a:xfrm>
+            <a:off x="868680" y="4992624"/>
+            <a:ext cx="3200400" cy="685800"/>
+          </a:xfrm>
+          <a:prstGeom prst="rect">
+            <a:avLst/>
+          </a:prstGeom>
+          <a:noFill/>
+        </p:spPr>
+        <p:txBody>
+          <a:bodyPr wrap="square">
+            <a:spAutoFit/>
+          </a:bodyPr>
+          <a:lstStyle/>
+          <a:p>
+            <a:pPr algn="l"/>
+            <a:r>
+              <a:rPr sz="1250" b="0" i="0">
+                <a:solidFill>
+                  <a:srgbClr val="F5F5F0"/>
+                </a:solidFill>
+                <a:latin typeface="Calibri"/>
+              </a:rPr>
+              <a:t>HP = Dashboard
+kandang 24 jam!</a:t>
+            </a:r>
+          </a:p>
+        </p:txBody>
+      </p:sp>
+      <p:sp>
+        <p:nvSpPr>
+          <p:cNvPr id="49" name="Rounded Rectangle 48"/>
+          <p:cNvSpPr/>
+          <p:nvPr/>
+        </p:nvSpPr>
+        <p:spPr>
+          <a:xfrm>
+            <a:off x="384048" y="5541264"/>
+            <a:ext cx="868680" cy="228600"/>
+          </a:xfrm>
+          <a:prstGeom prst="roundRect">
+            <a:avLst>
+              <a:gd name="adj" fmla="val 40000"/>
+            </a:avLst>
+          </a:prstGeom>
+          <a:solidFill>
+            <a:srgbClr val="F5A623"/>
+          </a:solidFill>
+          <a:ln>
+            <a:noFill/>
+          </a:ln>
+        </p:spPr>
+        <p:style>
+          <a:lnRef idx="1">
+            <a:schemeClr val="accent1"/>
+          </a:lnRef>
+          <a:fillRef idx="3">
+            <a:schemeClr val="accent1"/>
+          </a:fillRef>
+          <a:effectRef idx="2">
+            <a:schemeClr val="accent1"/>
+          </a:effectRef>
+          <a:fontRef idx="minor">
+            <a:schemeClr val="lt1"/>
+          </a:fontRef>
+        </p:style>
+        <p:txBody>
+          <a:bodyPr rtlCol="0" anchor="ctr"/>
+          <a:lstStyle/>
+          <a:p>
+            <a:pPr algn="ctr"/>
+          </a:p>
+        </p:txBody>
+      </p:sp>
+      <p:sp>
+        <p:nvSpPr>
+          <p:cNvPr id="50" name="TextBox 49"/>
+          <p:cNvSpPr txBox="1"/>
+          <p:nvPr/>
+        </p:nvSpPr>
+        <p:spPr>
+          <a:xfrm>
+            <a:off x="384048" y="5550408"/>
+            <a:ext cx="850392" cy="210312"/>
+          </a:xfrm>
+          <a:prstGeom prst="rect">
+            <a:avLst/>
+          </a:prstGeom>
+          <a:noFill/>
+        </p:spPr>
+        <p:txBody>
+          <a:bodyPr wrap="square">
+            <a:spAutoFit/>
+          </a:bodyPr>
+          <a:lstStyle/>
+          <a:p>
+            <a:pPr algn="ctr"/>
+            <a:r>
+              <a:rPr sz="1000" b="1" i="0">
+                <a:solidFill>
+                  <a:srgbClr val="282828"/>
+                </a:solidFill>
+                <a:latin typeface="Calibri"/>
+              </a:rPr>
+              <a:t>✨ BARU!</a:t>
+            </a:r>
+          </a:p>
+        </p:txBody>
+      </p:sp>
+      <p:sp>
+        <p:nvSpPr>
+          <p:cNvPr id="51" name="Rounded Rectangle 50"/>
+          <p:cNvSpPr/>
+          <p:nvPr/>
+        </p:nvSpPr>
+        <p:spPr>
+          <a:xfrm>
+            <a:off x="4306824" y="4425696"/>
+            <a:ext cx="3931920" cy="1417320"/>
+          </a:xfrm>
+          <a:prstGeom prst="roundRect">
+            <a:avLst>
+              <a:gd name="adj" fmla="val 5000"/>
+            </a:avLst>
+          </a:prstGeom>
+          <a:solidFill>
+            <a:srgbClr val="07578C"/>
+          </a:solidFill>
+          <a:ln>
+            <a:noFill/>
+          </a:ln>
+        </p:spPr>
+        <p:style>
+          <a:lnRef idx="1">
+            <a:schemeClr val="accent1"/>
+          </a:lnRef>
+          <a:fillRef idx="3">
+            <a:schemeClr val="accent1"/>
+          </a:fillRef>
+          <a:effectRef idx="2">
+            <a:schemeClr val="accent1"/>
+          </a:effectRef>
+          <a:fontRef idx="minor">
+            <a:schemeClr val="lt1"/>
+          </a:fontRef>
+        </p:style>
+        <p:txBody>
+          <a:bodyPr rtlCol="0" anchor="ctr"/>
+          <a:lstStyle/>
+          <a:p>
+            <a:pPr algn="ctr"/>
+          </a:p>
+        </p:txBody>
+      </p:sp>
+      <p:sp>
+        <p:nvSpPr>
+          <p:cNvPr id="52" name="Rounded Rectangle 51"/>
+          <p:cNvSpPr/>
+          <p:nvPr/>
+        </p:nvSpPr>
+        <p:spPr>
+          <a:xfrm>
+            <a:off x="4416552" y="4535424"/>
+            <a:ext cx="411480" cy="411480"/>
+          </a:xfrm>
+          <a:prstGeom prst="roundRect">
+            <a:avLst>
+              <a:gd name="adj" fmla="val 50000"/>
+            </a:avLst>
+          </a:prstGeom>
+          <a:solidFill>
+            <a:srgbClr val="249EDA"/>
+          </a:solidFill>
+          <a:ln>
+            <a:noFill/>
+          </a:ln>
+        </p:spPr>
+        <p:style>
+          <a:lnRef idx="1">
+            <a:schemeClr val="accent1"/>
+          </a:lnRef>
+          <a:fillRef idx="3">
+            <a:schemeClr val="accent1"/>
+          </a:fillRef>
+          <a:effectRef idx="2">
+            <a:schemeClr val="accent1"/>
+          </a:effectRef>
+          <a:fontRef idx="minor">
+            <a:schemeClr val="lt1"/>
+          </a:fontRef>
+        </p:style>
+        <p:txBody>
+          <a:bodyPr rtlCol="0" anchor="ctr"/>
+          <a:lstStyle/>
+          <a:p>
+            <a:pPr algn="ctr"/>
+          </a:p>
+        </p:txBody>
+      </p:sp>
+      <p:sp>
+        <p:nvSpPr>
+          <p:cNvPr id="53" name="TextBox 52"/>
+          <p:cNvSpPr txBox="1"/>
+          <p:nvPr/>
+        </p:nvSpPr>
+        <p:spPr>
+          <a:xfrm>
+            <a:off x="4416552" y="4562856"/>
+            <a:ext cx="411480" cy="347472"/>
+          </a:xfrm>
+          <a:prstGeom prst="rect">
+            <a:avLst/>
+          </a:prstGeom>
+          <a:noFill/>
+        </p:spPr>
+        <p:txBody>
+          <a:bodyPr wrap="square">
+            <a:spAutoFit/>
+          </a:bodyPr>
+          <a:lstStyle/>
+          <a:p>
+            <a:pPr algn="ctr"/>
+            <a:r>
+              <a:rPr sz="1400" b="1" i="0">
+                <a:solidFill>
+                  <a:srgbClr val="FFFFFF"/>
+                </a:solidFill>
+                <a:latin typeface="Calibri"/>
+              </a:rPr>
+              <a:t>08</a:t>
+            </a:r>
+          </a:p>
+        </p:txBody>
+      </p:sp>
+      <p:sp>
+        <p:nvSpPr>
+          <p:cNvPr id="54" name="TextBox 53"/>
+          <p:cNvSpPr txBox="1"/>
+          <p:nvPr/>
+        </p:nvSpPr>
+        <p:spPr>
+          <a:xfrm>
+            <a:off x="7671816" y="4517136"/>
+            <a:ext cx="457200" cy="457200"/>
+          </a:xfrm>
+          <a:prstGeom prst="rect">
+            <a:avLst/>
+          </a:prstGeom>
+          <a:noFill/>
+        </p:spPr>
+        <p:txBody>
+          <a:bodyPr wrap="square">
+            <a:spAutoFit/>
+          </a:bodyPr>
+          <a:lstStyle/>
+          <a:p>
+            <a:pPr algn="l"/>
+            <a:r>
+              <a:rPr sz="2400" b="0" i="0">
+                <a:solidFill>
+                  <a:srgbClr val="FFFFFF"/>
+                </a:solidFill>
+                <a:latin typeface="Segoe UI Emoji"/>
+              </a:rPr>
+              <a:t>🧪</a:t>
+            </a:r>
+          </a:p>
+        </p:txBody>
+      </p:sp>
+      <p:sp>
+        <p:nvSpPr>
+          <p:cNvPr id="55" name="TextBox 54"/>
+          <p:cNvSpPr txBox="1"/>
+          <p:nvPr/>
+        </p:nvSpPr>
+        <p:spPr>
+          <a:xfrm>
+            <a:off x="4901184" y="4553712"/>
+            <a:ext cx="3200400" cy="411480"/>
+          </a:xfrm>
+          <a:prstGeom prst="rect">
+            <a:avLst/>
+          </a:prstGeom>
+          <a:noFill/>
+        </p:spPr>
+        <p:txBody>
+          <a:bodyPr wrap="square">
+            <a:spAutoFit/>
+          </a:bodyPr>
+          <a:lstStyle/>
+          <a:p>
+            <a:pPr algn="l"/>
+            <a:r>
+              <a:rPr sz="1600" b="1" i="0">
+                <a:solidFill>
+                  <a:srgbClr val="249EDA"/>
+                </a:solidFill>
+                <a:latin typeface="Calibri"/>
+              </a:rPr>
+              <a:t>Praktikum Wokwi</a:t>
+            </a:r>
+          </a:p>
+        </p:txBody>
+      </p:sp>
+      <p:sp>
+        <p:nvSpPr>
+          <p:cNvPr id="56" name="TextBox 55"/>
+          <p:cNvSpPr txBox="1"/>
+          <p:nvPr/>
+        </p:nvSpPr>
+        <p:spPr>
+          <a:xfrm>
+            <a:off x="4901184" y="4992624"/>
+            <a:ext cx="3200400" cy="685800"/>
+          </a:xfrm>
+          <a:prstGeom prst="rect">
+            <a:avLst/>
+          </a:prstGeom>
+          <a:noFill/>
+        </p:spPr>
+        <p:txBody>
+          <a:bodyPr wrap="square">
+            <a:spAutoFit/>
+          </a:bodyPr>
+          <a:lstStyle/>
+          <a:p>
+            <a:pPr algn="l"/>
+            <a:r>
+              <a:rPr sz="1250" b="0" i="0">
+                <a:solidFill>
+                  <a:srgbClr val="F5F5F0"/>
+                </a:solidFill>
+                <a:latin typeface="Calibri"/>
+              </a:rPr>
+              <a:t>Simulasi IoT
+tanpa hardware</a:t>
+            </a:r>
+          </a:p>
+        </p:txBody>
+      </p:sp>
+      <p:sp>
+        <p:nvSpPr>
+          <p:cNvPr id="57" name="Rounded Rectangle 56"/>
+          <p:cNvSpPr/>
+          <p:nvPr/>
+        </p:nvSpPr>
+        <p:spPr>
+          <a:xfrm>
+            <a:off x="4416552" y="5541264"/>
+            <a:ext cx="868680" cy="228600"/>
+          </a:xfrm>
+          <a:prstGeom prst="roundRect">
+            <a:avLst>
+              <a:gd name="adj" fmla="val 40000"/>
+            </a:avLst>
+          </a:prstGeom>
+          <a:solidFill>
+            <a:srgbClr val="F5A623"/>
+          </a:solidFill>
+          <a:ln>
+            <a:noFill/>
+          </a:ln>
+        </p:spPr>
+        <p:style>
+          <a:lnRef idx="1">
+            <a:schemeClr val="accent1"/>
+          </a:lnRef>
+          <a:fillRef idx="3">
+            <a:schemeClr val="accent1"/>
+          </a:fillRef>
+          <a:effectRef idx="2">
+            <a:schemeClr val="accent1"/>
+          </a:effectRef>
+          <a:fontRef idx="minor">
+            <a:schemeClr val="lt1"/>
+          </a:fontRef>
+        </p:style>
+        <p:txBody>
+          <a:bodyPr rtlCol="0" anchor="ctr"/>
+          <a:lstStyle/>
+          <a:p>
+            <a:pPr algn="ctr"/>
+          </a:p>
+        </p:txBody>
+      </p:sp>
+      <p:sp>
+        <p:nvSpPr>
+          <p:cNvPr id="58" name="TextBox 57"/>
+          <p:cNvSpPr txBox="1"/>
+          <p:nvPr/>
+        </p:nvSpPr>
+        <p:spPr>
+          <a:xfrm>
+            <a:off x="4416552" y="5550408"/>
+            <a:ext cx="850392" cy="210312"/>
+          </a:xfrm>
+          <a:prstGeom prst="rect">
+            <a:avLst/>
+          </a:prstGeom>
+          <a:noFill/>
+        </p:spPr>
+        <p:txBody>
+          <a:bodyPr wrap="square">
+            <a:spAutoFit/>
+          </a:bodyPr>
+          <a:lstStyle/>
+          <a:p>
+            <a:pPr algn="ctr"/>
+            <a:r>
+              <a:rPr sz="1000" b="1" i="0">
+                <a:solidFill>
+                  <a:srgbClr val="282828"/>
+                </a:solidFill>
+                <a:latin typeface="Calibri"/>
+              </a:rPr>
+              <a:t>✨ BARU!</a:t>
+            </a:r>
+          </a:p>
+        </p:txBody>
+      </p:sp>
+      <p:sp>
+        <p:nvSpPr>
+          <p:cNvPr id="59" name="Rounded Rectangle 58"/>
+          <p:cNvSpPr/>
+          <p:nvPr/>
+        </p:nvSpPr>
+        <p:spPr>
+          <a:xfrm>
+            <a:off x="8339328" y="4425696"/>
+            <a:ext cx="3931920" cy="1417320"/>
+          </a:xfrm>
+          <a:prstGeom prst="roundRect">
+            <a:avLst>
+              <a:gd name="adj" fmla="val 5000"/>
             </a:avLst>
           </a:prstGeom>
           <a:solidFill>
@@ -21340,138 +22200,30 @@
           <a:lstStyle/>
           <a:p>
             <a:pPr algn="ctr"/>
-            <a:endParaRPr sz="2400"/>
-          </a:p>
-        </p:txBody>
-      </p:sp>
-      <p:sp>
-        <p:nvSpPr>
-          <p:cNvPr id="38" name="TextBox 37"/>
-          <p:cNvSpPr txBox="1"/>
-          <p:nvPr/>
-        </p:nvSpPr>
-        <p:spPr>
-          <a:xfrm>
-            <a:off x="6309360" y="4288536"/>
-            <a:ext cx="475488" cy="369332"/>
-          </a:xfrm>
-          <a:prstGeom prst="rect">
-            <a:avLst/>
-          </a:prstGeom>
-          <a:noFill/>
-        </p:spPr>
-        <p:txBody>
-          <a:bodyPr wrap="square">
-            <a:spAutoFit/>
-          </a:bodyPr>
-          <a:lstStyle/>
-          <a:p>
-            <a:pPr algn="ctr"/>
-            <a:r>
-              <a:rPr b="1" i="0">
-                <a:solidFill>
-                  <a:srgbClr val="FFFFFF"/>
-                </a:solidFill>
-                <a:latin typeface="Calibri"/>
-              </a:rPr>
-              <a:t>07</a:t>
-            </a:r>
-          </a:p>
-        </p:txBody>
-      </p:sp>
-      <p:sp>
-        <p:nvSpPr>
-          <p:cNvPr id="39" name="TextBox 38"/>
-          <p:cNvSpPr txBox="1"/>
-          <p:nvPr/>
-        </p:nvSpPr>
-        <p:spPr>
-          <a:xfrm>
-            <a:off x="6903720" y="4105656"/>
-            <a:ext cx="4754880" cy="400110"/>
-          </a:xfrm>
-          <a:prstGeom prst="rect">
-            <a:avLst/>
-          </a:prstGeom>
-          <a:noFill/>
-        </p:spPr>
-        <p:txBody>
-          <a:bodyPr wrap="square">
-            <a:spAutoFit/>
-          </a:bodyPr>
-          <a:lstStyle/>
-          <a:p>
-            <a:pPr algn="l"/>
-            <a:r>
-              <a:rPr sz="2000" b="1" i="0">
-                <a:solidFill>
-                  <a:srgbClr val="1B562E"/>
-                </a:solidFill>
-                <a:latin typeface="Segoe UI Emoji"/>
-              </a:rPr>
-              <a:t>⚠️  Tantangan &amp; Glosarium</a:t>
-            </a:r>
-          </a:p>
-        </p:txBody>
-      </p:sp>
-      <p:sp>
-        <p:nvSpPr>
-          <p:cNvPr id="40" name="TextBox 39"/>
-          <p:cNvSpPr txBox="1"/>
-          <p:nvPr/>
-        </p:nvSpPr>
-        <p:spPr>
-          <a:xfrm>
-            <a:off x="6903720" y="4626864"/>
-            <a:ext cx="4754880" cy="338554"/>
-          </a:xfrm>
-          <a:prstGeom prst="rect">
-            <a:avLst/>
-          </a:prstGeom>
-          <a:noFill/>
-        </p:spPr>
-        <p:txBody>
-          <a:bodyPr wrap="square">
-            <a:spAutoFit/>
-          </a:bodyPr>
-          <a:lstStyle/>
-          <a:p>
-            <a:pPr algn="l"/>
-            <a:r>
-              <a:rPr sz="1600" b="0" i="0">
-                <a:solidFill>
-                  <a:srgbClr val="444444"/>
-                </a:solidFill>
-                <a:latin typeface="Calibri"/>
-              </a:rPr>
-              <a:t>Kendala lapangan &amp; kamus istilah pemula</a:t>
-            </a:r>
-          </a:p>
-        </p:txBody>
-      </p:sp>
-      <p:sp>
-        <p:nvSpPr>
-          <p:cNvPr id="41" name="Rounded Rectangle 40"/>
+          </a:p>
+        </p:txBody>
+      </p:sp>
+      <p:sp>
+        <p:nvSpPr>
+          <p:cNvPr id="60" name="Rounded Rectangle 59"/>
           <p:cNvSpPr/>
           <p:nvPr/>
         </p:nvSpPr>
         <p:spPr>
           <a:xfrm>
-            <a:off x="6172200" y="5266944"/>
-            <a:ext cx="5623560" cy="1170432"/>
+            <a:off x="8449056" y="4535424"/>
+            <a:ext cx="411480" cy="411480"/>
           </a:xfrm>
           <a:prstGeom prst="roundRect">
             <a:avLst>
-              <a:gd name="adj" fmla="val 4000"/>
+              <a:gd name="adj" fmla="val 50000"/>
             </a:avLst>
           </a:prstGeom>
           <a:solidFill>
-            <a:srgbClr val="FFFFFF"/>
+            <a:srgbClr val="6FBF73"/>
           </a:solidFill>
-          <a:ln w="19050">
-            <a:solidFill>
-              <a:srgbClr val="6FBF73"/>
-            </a:solidFill>
+          <a:ln>
+            <a:noFill/>
           </a:ln>
         </p:spPr>
         <p:style>
@@ -21493,28 +22245,168 @@
           <a:lstStyle/>
           <a:p>
             <a:pPr algn="ctr"/>
-            <a:endParaRPr sz="2400"/>
-          </a:p>
-        </p:txBody>
-      </p:sp>
-      <p:sp>
-        <p:nvSpPr>
-          <p:cNvPr id="42" name="Rounded Rectangle 41"/>
+          </a:p>
+        </p:txBody>
+      </p:sp>
+      <p:sp>
+        <p:nvSpPr>
+          <p:cNvPr id="61" name="TextBox 60"/>
+          <p:cNvSpPr txBox="1"/>
+          <p:nvPr/>
+        </p:nvSpPr>
+        <p:spPr>
+          <a:xfrm>
+            <a:off x="8449056" y="4562856"/>
+            <a:ext cx="411480" cy="347472"/>
+          </a:xfrm>
+          <a:prstGeom prst="rect">
+            <a:avLst/>
+          </a:prstGeom>
+          <a:noFill/>
+        </p:spPr>
+        <p:txBody>
+          <a:bodyPr wrap="square">
+            <a:spAutoFit/>
+          </a:bodyPr>
+          <a:lstStyle/>
+          <a:p>
+            <a:pPr algn="ctr"/>
+            <a:r>
+              <a:rPr sz="1400" b="1" i="0">
+                <a:solidFill>
+                  <a:srgbClr val="0D1F14"/>
+                </a:solidFill>
+                <a:latin typeface="Calibri"/>
+              </a:rPr>
+              <a:t>09</a:t>
+            </a:r>
+          </a:p>
+        </p:txBody>
+      </p:sp>
+      <p:sp>
+        <p:nvSpPr>
+          <p:cNvPr id="62" name="TextBox 61"/>
+          <p:cNvSpPr txBox="1"/>
+          <p:nvPr/>
+        </p:nvSpPr>
+        <p:spPr>
+          <a:xfrm>
+            <a:off x="11704320" y="4517136"/>
+            <a:ext cx="457200" cy="457200"/>
+          </a:xfrm>
+          <a:prstGeom prst="rect">
+            <a:avLst/>
+          </a:prstGeom>
+          <a:noFill/>
+        </p:spPr>
+        <p:txBody>
+          <a:bodyPr wrap="square">
+            <a:spAutoFit/>
+          </a:bodyPr>
+          <a:lstStyle/>
+          <a:p>
+            <a:pPr algn="l"/>
+            <a:r>
+              <a:rPr sz="2400" b="0" i="0">
+                <a:solidFill>
+                  <a:srgbClr val="FFFFFF"/>
+                </a:solidFill>
+                <a:latin typeface="Segoe UI Emoji"/>
+              </a:rPr>
+              <a:t>💡</a:t>
+            </a:r>
+          </a:p>
+        </p:txBody>
+      </p:sp>
+      <p:sp>
+        <p:nvSpPr>
+          <p:cNvPr id="63" name="TextBox 62"/>
+          <p:cNvSpPr txBox="1"/>
+          <p:nvPr/>
+        </p:nvSpPr>
+        <p:spPr>
+          <a:xfrm>
+            <a:off x="8933688" y="4553712"/>
+            <a:ext cx="3200400" cy="411480"/>
+          </a:xfrm>
+          <a:prstGeom prst="rect">
+            <a:avLst/>
+          </a:prstGeom>
+          <a:noFill/>
+        </p:spPr>
+        <p:txBody>
+          <a:bodyPr wrap="square">
+            <a:spAutoFit/>
+          </a:bodyPr>
+          <a:lstStyle/>
+          <a:p>
+            <a:pPr algn="l"/>
+            <a:r>
+              <a:rPr sz="1600" b="1" i="0">
+                <a:solidFill>
+                  <a:srgbClr val="FFFFFF"/>
+                </a:solidFill>
+                <a:latin typeface="Calibri"/>
+              </a:rPr>
+              <a:t>Kesimpulan</a:t>
+            </a:r>
+          </a:p>
+        </p:txBody>
+      </p:sp>
+      <p:sp>
+        <p:nvSpPr>
+          <p:cNvPr id="64" name="TextBox 63"/>
+          <p:cNvSpPr txBox="1"/>
+          <p:nvPr/>
+        </p:nvSpPr>
+        <p:spPr>
+          <a:xfrm>
+            <a:off x="8933688" y="4992624"/>
+            <a:ext cx="3200400" cy="685800"/>
+          </a:xfrm>
+          <a:prstGeom prst="rect">
+            <a:avLst/>
+          </a:prstGeom>
+          <a:noFill/>
+        </p:spPr>
+        <p:txBody>
+          <a:bodyPr wrap="square">
+            <a:spAutoFit/>
+          </a:bodyPr>
+          <a:lstStyle/>
+          <a:p>
+            <a:pPr algn="l"/>
+            <a:r>
+              <a:rPr sz="1250" b="0" i="0">
+                <a:solidFill>
+                  <a:srgbClr val="F5F5F0"/>
+                </a:solidFill>
+                <a:latin typeface="Calibri"/>
+              </a:rPr>
+              <a:t>Poin penting &amp;
+langkah selanjutnya</a:t>
+            </a:r>
+          </a:p>
+        </p:txBody>
+      </p:sp>
+      <p:sp>
+        <p:nvSpPr>
+          <p:cNvPr id="65" name="Rounded Rectangle 64"/>
           <p:cNvSpPr/>
           <p:nvPr/>
         </p:nvSpPr>
         <p:spPr>
           <a:xfrm>
-            <a:off x="6309360" y="5586984"/>
-            <a:ext cx="475488" cy="475488"/>
+            <a:off x="274320" y="6492240"/>
+            <a:ext cx="11612880" cy="301752"/>
           </a:xfrm>
           <a:prstGeom prst="roundRect">
             <a:avLst>
-              <a:gd name="adj" fmla="val 10000"/>
+              <a:gd name="adj" fmla="val 4000"/>
             </a:avLst>
           </a:prstGeom>
           <a:solidFill>
-            <a:srgbClr val="1B562E"/>
+            <a:srgbClr val="2E8B57"/>
           </a:solidFill>
           <a:ln>
             <a:noFill/>
@@ -21539,111 +22431,40 @@
           <a:lstStyle/>
           <a:p>
             <a:pPr algn="ctr"/>
-            <a:endParaRPr sz="2400"/>
-          </a:p>
-        </p:txBody>
-      </p:sp>
-      <p:sp>
-        <p:nvSpPr>
-          <p:cNvPr id="43" name="TextBox 42"/>
-          <p:cNvSpPr txBox="1"/>
-          <p:nvPr/>
-        </p:nvSpPr>
-        <p:spPr>
-          <a:xfrm>
-            <a:off x="6309360" y="5586984"/>
-            <a:ext cx="475488" cy="369332"/>
-          </a:xfrm>
-          <a:prstGeom prst="rect">
-            <a:avLst/>
-          </a:prstGeom>
-          <a:noFill/>
-        </p:spPr>
-        <p:txBody>
-          <a:bodyPr wrap="square">
-            <a:spAutoFit/>
-          </a:bodyPr>
-          <a:lstStyle/>
-          <a:p>
-            <a:pPr algn="ctr"/>
-            <a:r>
-              <a:rPr b="1" i="0">
-                <a:solidFill>
-                  <a:srgbClr val="FFFFFF"/>
-                </a:solidFill>
-                <a:latin typeface="Calibri"/>
-              </a:rPr>
-              <a:t>08</a:t>
-            </a:r>
-          </a:p>
-        </p:txBody>
-      </p:sp>
-      <p:sp>
-        <p:nvSpPr>
-          <p:cNvPr id="44" name="TextBox 43"/>
-          <p:cNvSpPr txBox="1"/>
-          <p:nvPr/>
-        </p:nvSpPr>
-        <p:spPr>
-          <a:xfrm>
-            <a:off x="6903720" y="5404104"/>
-            <a:ext cx="4754880" cy="400110"/>
-          </a:xfrm>
-          <a:prstGeom prst="rect">
-            <a:avLst/>
-          </a:prstGeom>
-          <a:noFill/>
-        </p:spPr>
-        <p:txBody>
-          <a:bodyPr wrap="square">
-            <a:spAutoFit/>
-          </a:bodyPr>
-          <a:lstStyle/>
-          <a:p>
-            <a:pPr algn="l"/>
-            <a:r>
-              <a:rPr sz="2000" b="1" i="0">
-                <a:solidFill>
-                  <a:srgbClr val="1B562E"/>
-                </a:solidFill>
-                <a:latin typeface="Segoe UI Emoji"/>
-              </a:rPr>
-              <a:t>🚀  Karir &amp; Langkah Awal</a:t>
-            </a:r>
-          </a:p>
-        </p:txBody>
-      </p:sp>
-      <p:sp>
-        <p:nvSpPr>
-          <p:cNvPr id="45" name="TextBox 44"/>
-          <p:cNvSpPr txBox="1"/>
-          <p:nvPr/>
-        </p:nvSpPr>
-        <p:spPr>
-          <a:xfrm>
-            <a:off x="6903720" y="5925312"/>
-            <a:ext cx="4754880" cy="338554"/>
-          </a:xfrm>
-          <a:prstGeom prst="rect">
-            <a:avLst/>
-          </a:prstGeom>
-          <a:noFill/>
-        </p:spPr>
-        <p:txBody>
-          <a:bodyPr wrap="square">
-            <a:spAutoFit/>
-          </a:bodyPr>
-          <a:lstStyle/>
-          <a:p>
-            <a:pPr algn="l"/>
-            <a:r>
-              <a:rPr sz="1600" b="0" i="0">
-                <a:solidFill>
-                  <a:srgbClr val="444444"/>
-                </a:solidFill>
-                <a:latin typeface="Calibri"/>
-              </a:rPr>
-              <a:t>Peluang emas masa depan kamu</a:t>
+          </a:p>
+        </p:txBody>
+      </p:sp>
+      <p:sp>
+        <p:nvSpPr>
+          <p:cNvPr id="66" name="TextBox 65"/>
+          <p:cNvSpPr txBox="1"/>
+          <p:nvPr/>
+        </p:nvSpPr>
+        <p:spPr>
+          <a:xfrm>
+            <a:off x="457200" y="6519672"/>
+            <a:ext cx="11247120" cy="256032"/>
+          </a:xfrm>
+          <a:prstGeom prst="rect">
+            <a:avLst/>
+          </a:prstGeom>
+          <a:noFill/>
+        </p:spPr>
+        <p:txBody>
+          <a:bodyPr wrap="square">
+            <a:spAutoFit/>
+          </a:bodyPr>
+          <a:lstStyle/>
+          <a:p>
+            <a:pPr algn="ctr"/>
+            <a:r>
+              <a:rPr sz="1300" b="1" i="0">
+                <a:solidFill>
+                  <a:srgbClr val="0D1F14"/>
+                </a:solidFill>
+                <a:latin typeface="Calibri"/>
+              </a:rPr>
+              <a:t>📊 Total: 22 Slide  |  🧪 Termasuk Wokwi Simulator  |  📱 Termasuk Telegram Bot Monitoring</a:t>
             </a:r>
           </a:p>
         </p:txBody>

</xml_diff>

<commit_message>
Update PPT: revisi manual dari dosen
</commit_message>
<xml_diff>
--- a/IoT_untuk_Peternakan_UNMUL.pptx
+++ b/IoT_untuk_Peternakan_UNMUL.pptx
@@ -15813,7 +15813,7 @@
         <p:spPr>
           <a:xfrm>
             <a:off x="987552" y="1554480"/>
-            <a:ext cx="2011680" cy="338554"/>
+            <a:ext cx="2011680" cy="307777"/>
           </a:xfrm>
           <a:prstGeom prst="rect">
             <a:avLst/>
@@ -15828,13 +15828,22 @@
           <a:p>
             <a:pPr algn="l"/>
             <a:r>
-              <a:rPr sz="1600" b="1" i="0">
+              <a:rPr sz="1400" b="1" i="0" dirty="0" err="1">
                 <a:solidFill>
                   <a:srgbClr val="249EDA"/>
                 </a:solidFill>
                 <a:latin typeface="Calibri"/>
               </a:rPr>
-              <a:t>Buat Bot di Telegram</a:t>
+              <a:t>Buat</a:t>
+            </a:r>
+            <a:r>
+              <a:rPr sz="1400" b="1" i="0" dirty="0">
+                <a:solidFill>
+                  <a:srgbClr val="249EDA"/>
+                </a:solidFill>
+                <a:latin typeface="Calibri"/>
+              </a:rPr>
+              <a:t> Bot di Telegram</a:t>
             </a:r>
           </a:p>
         </p:txBody>
@@ -16471,7 +16480,24 @@
                 </a:solidFill>
                 <a:latin typeface="Calibri"/>
               </a:rPr>
-              <a:t>Cari @userinfobot di Telegram</a:t>
+              <a:t>Cari </a:t>
+            </a:r>
+            <a:r>
+              <a:rPr lang="id-ID" dirty="0">
+                <a:solidFill>
+                  <a:srgbClr val="F5F5F0"/>
+                </a:solidFill>
+              </a:rPr>
+              <a:t>@myidbot</a:t>
+            </a:r>
+            <a:r>
+              <a:rPr dirty="0">
+                <a:solidFill>
+                  <a:srgbClr val="F5F5F0"/>
+                </a:solidFill>
+                <a:latin typeface="Calibri"/>
+              </a:rPr>
+              <a:t> di Telegram</a:t>
             </a:r>
           </a:p>
           <a:p>

</xml_diff>